<commit_message>
Slide 1: today's CAPEE process on the left, what it is worth on the right
Back to the two-column layout, with the description of the existing
process taken from the four points supplied: trusted and thorough,
hands-on setup, manual data entry, updated by hand. The 12-to-69 figure
now sits on the manual-data-entry line where it belongs rather than
standing on its own.

The right column keeps the value model — the five numbers with four
boxes empty for JLR, and the three formulas underneath, reflowed as
single rows to fit the half-width column. The step-forward line closes
the slide full width.

Slides 2, 3 and 4 unchanged.

Co-Authored-By: Claude Opus 5 <noreply@anthropic.com>
Claude-Session: https://claude.ai/code/session_0142L4rKS2AV8rxQTDWMs7dy
</commit_message>
<xml_diff>
--- a/CostVision-CAPEE-Business-Case.pptx
+++ b/CostVision-CAPEE-Business-Case.pptx
@@ -508,7 +508,7 @@
           <a:lstStyle/>
           <a:p>
             <a:r>
-              <a:t>I want to start by saying what we do well, because the proposal is not a criticism of it. We cost parts properly. The method is bottom-up, it covers every commodity, and it is the number we would defend in front of a supplier. That is worth protecting and nothing I am about to propose changes it. What I want to talk about is the effort. Every one of those costings is set up by hand. A person chooses the material, the process and the machine. A person opens the 3D model and the drawing, reads the geometry and the tolerances, and types them in. Depending on the commodity that is somewhere between twelve and sixty-nine values per part, and those counts come straight off our own input forms. And when the economics move, somebody goes back in and updates the rates by hand. None of that is wrong. It is just slow, and it is why we cost the parts we have time for rather than the parts we would like to. The green strip is the whole idea in one line. Same method, same defensible answer, with the manual work taken out of it.</a:t>
+              <a:t>I want to start by saying what we do well, because none of this is a criticism of it. The left-hand card is our should-cost as it runs today. The method is trusted and thorough: a rigorous bottom-up build-up, applied across every commodity we buy, and it is the number we would defend in front of a supplier. Nothing I am about to propose changes that. What I want to talk about is the effort behind it. The setup is hands-on: a person chooses the material, the process and the machine, part by part. The data entry is manual: somebody opens the 3D model and the drawings, reads the geometry and the tolerances, and types them in. And when the economics move, somebody goes back and updates the rates by hand. The line at the bottom of that card is the size of it: between twelve and sixty-nine values typed per part depending on the commodity, and those counts come straight off our own input forms. None of that is wrong. It is just slow, and it is the reason we cost the parts we have time for rather than the parts we would like to. Now the right-hand side, and I want to be straight about why it is empty. I have not put a saving on this slide, because we have never timed this job and we have never compared this tool against a price we have actually paid. Any number I put there would be my estimate dressed up as a measurement. Four of these five are ours and we can get them quickly: how long a part takes, how much of that is reading and typing, how many parts we cost a year, and how many in a basket we never cost at all. Time a handful of parts in one commodity and you have the first two; the others are in our own records and the programme data. The fifth, E, is what the trial measures. Put those numbers in and the three boxes underneath fill themselves in: the hours we spend typing today, the hours we would get back, and how many more parts that time would cost. That is a business case we own rather than one I have handed you. And the green strip is the whole idea in one line: same method, same defensible answer, with the manual work taken out of it.</a:t>
             </a:r>
           </a:p>
         </p:txBody>
@@ -4072,7 +4072,7 @@
                 </a:solidFill>
                 <a:latin typeface="Calibri"/>
               </a:rPr>
-              <a:t>We already cost parts properly. The method is sound; the effort is manual — 12 to 69 values typed in for every part.</a:t>
+              <a:t>We already cost parts properly. On the left is that job as it runs today. On the right is what it is worth, in our own numbers.</a:t>
             </a:r>
           </a:p>
         </p:txBody>
@@ -4085,8 +4085,8 @@
         </p:nvSpPr>
         <p:spPr>
           <a:xfrm>
-            <a:off x="411480" y="1883664"/>
-            <a:ext cx="11365992" cy="868680"/>
+            <a:off x="411480" y="1792224"/>
+            <a:ext cx="5577840" cy="4114800"/>
           </a:xfrm>
           <a:prstGeom prst="roundRect">
             <a:avLst>
@@ -4133,14 +4133,14 @@
         </p:nvSpPr>
         <p:spPr>
           <a:xfrm>
-            <a:off x="411480" y="1883664"/>
-            <a:ext cx="68580" cy="868680"/>
+            <a:off x="411480" y="1792224"/>
+            <a:ext cx="68580" cy="4114800"/>
           </a:xfrm>
           <a:prstGeom prst="rect">
             <a:avLst/>
           </a:prstGeom>
           <a:solidFill>
-            <a:srgbClr val="2E8B57"/>
+            <a:srgbClr val="B7791F"/>
           </a:solidFill>
           <a:ln>
             <a:noFill/>
@@ -4169,40 +4169,16 @@
           </a:p>
         </p:txBody>
       </p:sp>
-      <p:pic>
-        <p:nvPicPr>
-          <p:cNvPr id="12" name="Picture 11" descr="check.png"/>
-          <p:cNvPicPr>
-            <a:picLocks noChangeAspect="1"/>
-          </p:cNvPicPr>
-          <p:nvPr/>
-        </p:nvPicPr>
-        <p:blipFill>
-          <a:blip r:embed="rId2"/>
-          <a:stretch>
-            <a:fillRect/>
-          </a:stretch>
-        </p:blipFill>
-        <p:spPr>
-          <a:xfrm>
-            <a:off x="801014" y="2186330"/>
-            <a:ext cx="263348" cy="263348"/>
-          </a:xfrm>
-          <a:prstGeom prst="rect">
-            <a:avLst/>
-          </a:prstGeom>
-        </p:spPr>
-      </p:pic>
-      <p:sp>
-        <p:nvSpPr>
-          <p:cNvPr id="13" name="TextBox 12"/>
+      <p:sp>
+        <p:nvSpPr>
+          <p:cNvPr id="12" name="TextBox 11"/>
           <p:cNvSpPr txBox="1"/>
           <p:nvPr/>
         </p:nvSpPr>
         <p:spPr>
           <a:xfrm>
-            <a:off x="1417320" y="2029968"/>
-            <a:ext cx="10131552" cy="256032"/>
+            <a:off x="612648" y="1920240"/>
+            <a:ext cx="5212080" cy="274320"/>
           </a:xfrm>
           <a:prstGeom prst="rect">
             <a:avLst/>
@@ -4224,15 +4200,258 @@
               </a:spcAft>
             </a:pPr>
             <a:r>
-              <a:rPr sz="1250" b="1" i="0">
+              <a:rPr sz="1300" b="1" i="0">
                 <a:solidFill>
                   <a:srgbClr val="16325C"/>
+                </a:solidFill>
+                <a:latin typeface="Calibri"/>
+              </a:rPr>
+              <a:t>OUR SHOULD-COST TODAY · capable, but hands-on</a:t>
+            </a:r>
+          </a:p>
+        </p:txBody>
+      </p:sp>
+      <p:sp>
+        <p:nvSpPr>
+          <p:cNvPr id="13" name="TextBox 12"/>
+          <p:cNvSpPr txBox="1"/>
+          <p:nvPr/>
+        </p:nvSpPr>
+        <p:spPr>
+          <a:xfrm>
+            <a:off x="612648" y="2231136"/>
+            <a:ext cx="5212080" cy="3566160"/>
+          </a:xfrm>
+          <a:prstGeom prst="rect">
+            <a:avLst/>
+          </a:prstGeom>
+          <a:noFill/>
+        </p:spPr>
+        <p:txBody>
+          <a:bodyPr wrap="square" anchor="t" lIns="0" rIns="0" tIns="0" bIns="0">
+            <a:spAutoFit/>
+          </a:bodyPr>
+          <a:lstStyle/>
+          <a:p>
+            <a:pPr algn="l">
+              <a:lnSpc>
+                <a:spcPct val="112000"/>
+              </a:lnSpc>
+              <a:spcAft>
+                <a:spcPts val="300"/>
+              </a:spcAft>
+            </a:pPr>
+            <a:r>
+              <a:rPr sz="1050" b="1" i="0">
+                <a:solidFill>
+                  <a:srgbClr val="2E8B57"/>
                 </a:solidFill>
                 <a:latin typeface="Calibri"/>
               </a:rPr>
               <a:t>Trusted and thorough</a:t>
             </a:r>
           </a:p>
+          <a:p>
+            <a:pPr algn="l">
+              <a:lnSpc>
+                <a:spcPct val="112000"/>
+              </a:lnSpc>
+              <a:spcAft>
+                <a:spcPts val="300"/>
+              </a:spcAft>
+            </a:pPr>
+            <a:r>
+              <a:rPr sz="1050" b="0" i="0">
+                <a:solidFill>
+                  <a:srgbClr val="3A4356"/>
+                </a:solidFill>
+                <a:latin typeface="Calibri"/>
+              </a:rPr>
+              <a:t>A rigorous bottom-up method, across every commodity.</a:t>
+            </a:r>
+          </a:p>
+          <a:p>
+            <a:pPr algn="l">
+              <a:lnSpc>
+                <a:spcPct val="112000"/>
+              </a:lnSpc>
+              <a:spcAft>
+                <a:spcPts val="300"/>
+              </a:spcAft>
+            </a:pPr>
+          </a:p>
+          <a:p>
+            <a:pPr algn="l">
+              <a:lnSpc>
+                <a:spcPct val="112000"/>
+              </a:lnSpc>
+              <a:spcAft>
+                <a:spcPts val="300"/>
+              </a:spcAft>
+            </a:pPr>
+            <a:r>
+              <a:rPr sz="1050" b="1" i="0">
+                <a:solidFill>
+                  <a:srgbClr val="16325C"/>
+                </a:solidFill>
+                <a:latin typeface="Calibri"/>
+              </a:rPr>
+              <a:t>Hands-on setup</a:t>
+            </a:r>
+          </a:p>
+          <a:p>
+            <a:pPr algn="l">
+              <a:lnSpc>
+                <a:spcPct val="112000"/>
+              </a:lnSpc>
+              <a:spcAft>
+                <a:spcPts val="300"/>
+              </a:spcAft>
+            </a:pPr>
+            <a:r>
+              <a:rPr sz="1050" b="0" i="0">
+                <a:solidFill>
+                  <a:srgbClr val="3A4356"/>
+                </a:solidFill>
+                <a:latin typeface="Calibri"/>
+              </a:rPr>
+              <a:t>Material, process and machine chosen by a person,</a:t>
+            </a:r>
+          </a:p>
+          <a:p>
+            <a:pPr algn="l">
+              <a:lnSpc>
+                <a:spcPct val="112000"/>
+              </a:lnSpc>
+              <a:spcAft>
+                <a:spcPts val="300"/>
+              </a:spcAft>
+            </a:pPr>
+            <a:r>
+              <a:rPr sz="1050" b="0" i="0">
+                <a:solidFill>
+                  <a:srgbClr val="3A4356"/>
+                </a:solidFill>
+                <a:latin typeface="Calibri"/>
+              </a:rPr>
+              <a:t>part by part.</a:t>
+            </a:r>
+          </a:p>
+          <a:p>
+            <a:pPr algn="l">
+              <a:lnSpc>
+                <a:spcPct val="112000"/>
+              </a:lnSpc>
+              <a:spcAft>
+                <a:spcPts val="300"/>
+              </a:spcAft>
+            </a:pPr>
+          </a:p>
+          <a:p>
+            <a:pPr algn="l">
+              <a:lnSpc>
+                <a:spcPct val="112000"/>
+              </a:lnSpc>
+              <a:spcAft>
+                <a:spcPts val="300"/>
+              </a:spcAft>
+            </a:pPr>
+            <a:r>
+              <a:rPr sz="1050" b="1" i="0">
+                <a:solidFill>
+                  <a:srgbClr val="16325C"/>
+                </a:solidFill>
+                <a:latin typeface="Calibri"/>
+              </a:rPr>
+              <a:t>Manual data entry</a:t>
+            </a:r>
+          </a:p>
+          <a:p>
+            <a:pPr algn="l">
+              <a:lnSpc>
+                <a:spcPct val="112000"/>
+              </a:lnSpc>
+              <a:spcAft>
+                <a:spcPts val="300"/>
+              </a:spcAft>
+            </a:pPr>
+            <a:r>
+              <a:rPr sz="1050" b="0" i="0">
+                <a:solidFill>
+                  <a:srgbClr val="3A4356"/>
+                </a:solidFill>
+                <a:latin typeface="Calibri"/>
+              </a:rPr>
+              <a:t>Geometry and tolerances read off the 3D model and the</a:t>
+            </a:r>
+          </a:p>
+          <a:p>
+            <a:pPr algn="l">
+              <a:lnSpc>
+                <a:spcPct val="112000"/>
+              </a:lnSpc>
+              <a:spcAft>
+                <a:spcPts val="300"/>
+              </a:spcAft>
+            </a:pPr>
+            <a:r>
+              <a:rPr sz="1050" b="0" i="0">
+                <a:solidFill>
+                  <a:srgbClr val="3A4356"/>
+                </a:solidFill>
+                <a:latin typeface="Calibri"/>
+              </a:rPr>
+              <a:t>drawings, then typed in — 12 to 69 values per part.</a:t>
+            </a:r>
+          </a:p>
+          <a:p>
+            <a:pPr algn="l">
+              <a:lnSpc>
+                <a:spcPct val="112000"/>
+              </a:lnSpc>
+              <a:spcAft>
+                <a:spcPts val="300"/>
+              </a:spcAft>
+            </a:pPr>
+          </a:p>
+          <a:p>
+            <a:pPr algn="l">
+              <a:lnSpc>
+                <a:spcPct val="112000"/>
+              </a:lnSpc>
+              <a:spcAft>
+                <a:spcPts val="300"/>
+              </a:spcAft>
+            </a:pPr>
+            <a:r>
+              <a:rPr sz="1050" b="1" i="0">
+                <a:solidFill>
+                  <a:srgbClr val="16325C"/>
+                </a:solidFill>
+                <a:latin typeface="Calibri"/>
+              </a:rPr>
+              <a:t>Updated by hand</a:t>
+            </a:r>
+          </a:p>
+          <a:p>
+            <a:pPr algn="l">
+              <a:lnSpc>
+                <a:spcPct val="112000"/>
+              </a:lnSpc>
+              <a:spcAft>
+                <a:spcPts val="300"/>
+              </a:spcAft>
+            </a:pPr>
+            <a:r>
+              <a:rPr sz="1050" b="0" i="0">
+                <a:solidFill>
+                  <a:srgbClr val="3A4356"/>
+                </a:solidFill>
+                <a:latin typeface="Calibri"/>
+              </a:rPr>
+              <a:t>Rates and inputs refreshed manually as economics move.</a:t>
+            </a:r>
+          </a:p>
         </p:txBody>
       </p:sp>
       <p:sp>
@@ -4243,8 +4462,8 @@
         </p:nvSpPr>
         <p:spPr>
           <a:xfrm>
-            <a:off x="1417320" y="2313432"/>
-            <a:ext cx="10131552" cy="365760"/>
+            <a:off x="6199632" y="1810512"/>
+            <a:ext cx="5577840" cy="274320"/>
           </a:xfrm>
           <a:prstGeom prst="rect">
             <a:avLst/>
@@ -4259,39 +4478,286 @@
           <a:p>
             <a:pPr algn="l">
               <a:lnSpc>
-                <a:spcPct val="113000"/>
+                <a:spcPct val="100000"/>
               </a:lnSpc>
               <a:spcAft>
                 <a:spcPts val="400"/>
               </a:spcAft>
             </a:pPr>
             <a:r>
-              <a:rPr sz="1019" b="0" i="0">
-                <a:solidFill>
-                  <a:srgbClr val="3A4356"/>
+              <a:rPr sz="1150" b="1" i="0">
+                <a:solidFill>
+                  <a:srgbClr val="6B7280"/>
                 </a:solidFill>
                 <a:latin typeface="Calibri"/>
               </a:rPr>
-              <a:t>A rigorous bottom-up method, applied across every commodity we buy.</a:t>
-            </a:r>
-          </a:p>
-        </p:txBody>
-      </p:sp>
-      <p:sp>
-        <p:nvSpPr>
-          <p:cNvPr id="15" name="Rounded Rectangle 14"/>
+              <a:t>What it is worth: five numbers, four of them ours</a:t>
+            </a:r>
+          </a:p>
+        </p:txBody>
+      </p:sp>
+      <p:sp>
+        <p:nvSpPr>
+          <p:cNvPr id="15" name="Rectangle 14"/>
           <p:cNvSpPr/>
           <p:nvPr/>
         </p:nvSpPr>
         <p:spPr>
           <a:xfrm>
-            <a:off x="411480" y="2816352"/>
-            <a:ext cx="11365992" cy="868680"/>
-          </a:xfrm>
-          <a:prstGeom prst="roundRect">
-            <a:avLst>
-              <a:gd name="adj" fmla="val 12000"/>
-            </a:avLst>
+            <a:off x="6199632" y="2066543"/>
+            <a:ext cx="411480" cy="329184"/>
+          </a:xfrm>
+          <a:prstGeom prst="rect">
+            <a:avLst/>
+          </a:prstGeom>
+          <a:solidFill>
+            <a:srgbClr val="16325C"/>
+          </a:solidFill>
+          <a:ln>
+            <a:noFill/>
+          </a:ln>
+          <a:effectLst/>
+        </p:spPr>
+        <p:style>
+          <a:lnRef idx="1">
+            <a:schemeClr val="accent1"/>
+          </a:lnRef>
+          <a:fillRef idx="3">
+            <a:schemeClr val="accent1"/>
+          </a:fillRef>
+          <a:effectRef idx="2">
+            <a:schemeClr val="accent1"/>
+          </a:effectRef>
+          <a:fontRef idx="minor">
+            <a:schemeClr val="lt1"/>
+          </a:fontRef>
+        </p:style>
+        <p:txBody>
+          <a:bodyPr rtlCol="0" anchor="ctr"/>
+          <a:lstStyle/>
+          <a:p>
+            <a:pPr algn="ctr"/>
+          </a:p>
+        </p:txBody>
+      </p:sp>
+      <p:sp>
+        <p:nvSpPr>
+          <p:cNvPr id="16" name="TextBox 15"/>
+          <p:cNvSpPr txBox="1"/>
+          <p:nvPr/>
+        </p:nvSpPr>
+        <p:spPr>
+          <a:xfrm>
+            <a:off x="6281928" y="2148839"/>
+            <a:ext cx="265176" cy="219456"/>
+          </a:xfrm>
+          <a:prstGeom prst="rect">
+            <a:avLst/>
+          </a:prstGeom>
+          <a:noFill/>
+        </p:spPr>
+        <p:txBody>
+          <a:bodyPr wrap="square" anchor="t" lIns="0" rIns="0" tIns="0" bIns="0">
+            <a:spAutoFit/>
+          </a:bodyPr>
+          <a:lstStyle/>
+          <a:p>
+            <a:pPr algn="l">
+              <a:lnSpc>
+                <a:spcPct val="100000"/>
+              </a:lnSpc>
+              <a:spcAft>
+                <a:spcPts val="400"/>
+              </a:spcAft>
+            </a:pPr>
+          </a:p>
+        </p:txBody>
+      </p:sp>
+      <p:sp>
+        <p:nvSpPr>
+          <p:cNvPr id="17" name="Rectangle 16"/>
+          <p:cNvSpPr/>
+          <p:nvPr/>
+        </p:nvSpPr>
+        <p:spPr>
+          <a:xfrm>
+            <a:off x="6611112" y="2066543"/>
+            <a:ext cx="3611880" cy="329184"/>
+          </a:xfrm>
+          <a:prstGeom prst="rect">
+            <a:avLst/>
+          </a:prstGeom>
+          <a:solidFill>
+            <a:srgbClr val="16325C"/>
+          </a:solidFill>
+          <a:ln>
+            <a:noFill/>
+          </a:ln>
+          <a:effectLst/>
+        </p:spPr>
+        <p:style>
+          <a:lnRef idx="1">
+            <a:schemeClr val="accent1"/>
+          </a:lnRef>
+          <a:fillRef idx="3">
+            <a:schemeClr val="accent1"/>
+          </a:fillRef>
+          <a:effectRef idx="2">
+            <a:schemeClr val="accent1"/>
+          </a:effectRef>
+          <a:fontRef idx="minor">
+            <a:schemeClr val="lt1"/>
+          </a:fontRef>
+        </p:style>
+        <p:txBody>
+          <a:bodyPr rtlCol="0" anchor="ctr"/>
+          <a:lstStyle/>
+          <a:p>
+            <a:pPr algn="ctr"/>
+          </a:p>
+        </p:txBody>
+      </p:sp>
+      <p:sp>
+        <p:nvSpPr>
+          <p:cNvPr id="18" name="TextBox 17"/>
+          <p:cNvSpPr txBox="1"/>
+          <p:nvPr/>
+        </p:nvSpPr>
+        <p:spPr>
+          <a:xfrm>
+            <a:off x="6693408" y="2148839"/>
+            <a:ext cx="3465576" cy="219456"/>
+          </a:xfrm>
+          <a:prstGeom prst="rect">
+            <a:avLst/>
+          </a:prstGeom>
+          <a:noFill/>
+        </p:spPr>
+        <p:txBody>
+          <a:bodyPr wrap="square" anchor="t" lIns="0" rIns="0" tIns="0" bIns="0">
+            <a:spAutoFit/>
+          </a:bodyPr>
+          <a:lstStyle/>
+          <a:p>
+            <a:pPr algn="l">
+              <a:lnSpc>
+                <a:spcPct val="100000"/>
+              </a:lnSpc>
+              <a:spcAft>
+                <a:spcPts val="400"/>
+              </a:spcAft>
+            </a:pPr>
+            <a:r>
+              <a:rPr sz="950" b="1" i="0">
+                <a:solidFill>
+                  <a:srgbClr val="FFFFFF"/>
+                </a:solidFill>
+                <a:latin typeface="Calibri"/>
+              </a:rPr>
+              <a:t>What it is</a:t>
+            </a:r>
+          </a:p>
+        </p:txBody>
+      </p:sp>
+      <p:sp>
+        <p:nvSpPr>
+          <p:cNvPr id="19" name="Rectangle 18"/>
+          <p:cNvSpPr/>
+          <p:nvPr/>
+        </p:nvSpPr>
+        <p:spPr>
+          <a:xfrm>
+            <a:off x="10222992" y="2066543"/>
+            <a:ext cx="1554480" cy="329184"/>
+          </a:xfrm>
+          <a:prstGeom prst="rect">
+            <a:avLst/>
+          </a:prstGeom>
+          <a:solidFill>
+            <a:srgbClr val="16325C"/>
+          </a:solidFill>
+          <a:ln>
+            <a:noFill/>
+          </a:ln>
+          <a:effectLst/>
+        </p:spPr>
+        <p:style>
+          <a:lnRef idx="1">
+            <a:schemeClr val="accent1"/>
+          </a:lnRef>
+          <a:fillRef idx="3">
+            <a:schemeClr val="accent1"/>
+          </a:fillRef>
+          <a:effectRef idx="2">
+            <a:schemeClr val="accent1"/>
+          </a:effectRef>
+          <a:fontRef idx="minor">
+            <a:schemeClr val="lt1"/>
+          </a:fontRef>
+        </p:style>
+        <p:txBody>
+          <a:bodyPr rtlCol="0" anchor="ctr"/>
+          <a:lstStyle/>
+          <a:p>
+            <a:pPr algn="ctr"/>
+          </a:p>
+        </p:txBody>
+      </p:sp>
+      <p:sp>
+        <p:nvSpPr>
+          <p:cNvPr id="20" name="TextBox 19"/>
+          <p:cNvSpPr txBox="1"/>
+          <p:nvPr/>
+        </p:nvSpPr>
+        <p:spPr>
+          <a:xfrm>
+            <a:off x="10305288" y="2148839"/>
+            <a:ext cx="1408176" cy="219456"/>
+          </a:xfrm>
+          <a:prstGeom prst="rect">
+            <a:avLst/>
+          </a:prstGeom>
+          <a:noFill/>
+        </p:spPr>
+        <p:txBody>
+          <a:bodyPr wrap="square" anchor="t" lIns="0" rIns="0" tIns="0" bIns="0">
+            <a:spAutoFit/>
+          </a:bodyPr>
+          <a:lstStyle/>
+          <a:p>
+            <a:pPr algn="l">
+              <a:lnSpc>
+                <a:spcPct val="100000"/>
+              </a:lnSpc>
+              <a:spcAft>
+                <a:spcPts val="400"/>
+              </a:spcAft>
+            </a:pPr>
+            <a:r>
+              <a:rPr sz="950" b="1" i="0">
+                <a:solidFill>
+                  <a:srgbClr val="FFFFFF"/>
+                </a:solidFill>
+                <a:latin typeface="Calibri"/>
+              </a:rPr>
+              <a:t>Our number</a:t>
+            </a:r>
+          </a:p>
+        </p:txBody>
+      </p:sp>
+      <p:sp>
+        <p:nvSpPr>
+          <p:cNvPr id="21" name="Rectangle 20"/>
+          <p:cNvSpPr/>
+          <p:nvPr/>
+        </p:nvSpPr>
+        <p:spPr>
+          <a:xfrm>
+            <a:off x="6199632" y="2395727"/>
+            <a:ext cx="411480" cy="310896"/>
+          </a:xfrm>
+          <a:prstGeom prst="rect">
+            <a:avLst/>
           </a:prstGeom>
           <a:solidFill>
             <a:srgbClr val="FFFFFF"/>
@@ -4327,126 +4793,14 @@
       </p:sp>
       <p:sp>
         <p:nvSpPr>
-          <p:cNvPr id="16" name="Rectangle 15"/>
-          <p:cNvSpPr/>
-          <p:nvPr/>
-        </p:nvSpPr>
-        <p:spPr>
-          <a:xfrm>
-            <a:off x="411480" y="2816352"/>
-            <a:ext cx="68580" cy="868680"/>
-          </a:xfrm>
-          <a:prstGeom prst="rect">
-            <a:avLst/>
-          </a:prstGeom>
-          <a:solidFill>
-            <a:srgbClr val="B7791F"/>
-          </a:solidFill>
-          <a:ln>
-            <a:noFill/>
-          </a:ln>
-          <a:effectLst/>
-        </p:spPr>
-        <p:style>
-          <a:lnRef idx="1">
-            <a:schemeClr val="accent1"/>
-          </a:lnRef>
-          <a:fillRef idx="3">
-            <a:schemeClr val="accent1"/>
-          </a:fillRef>
-          <a:effectRef idx="2">
-            <a:schemeClr val="accent1"/>
-          </a:effectRef>
-          <a:fontRef idx="minor">
-            <a:schemeClr val="lt1"/>
-          </a:fontRef>
-        </p:style>
-        <p:txBody>
-          <a:bodyPr rtlCol="0" anchor="ctr"/>
-          <a:lstStyle/>
-          <a:p>
-            <a:pPr algn="ctr"/>
-          </a:p>
-        </p:txBody>
-      </p:sp>
-      <p:sp>
-        <p:nvSpPr>
-          <p:cNvPr id="17" name="Oval 16"/>
-          <p:cNvSpPr/>
-          <p:nvPr/>
-        </p:nvSpPr>
-        <p:spPr>
-          <a:xfrm>
-            <a:off x="658368" y="2976372"/>
-            <a:ext cx="548640" cy="548640"/>
-          </a:xfrm>
-          <a:prstGeom prst="ellipse">
-            <a:avLst/>
-          </a:prstGeom>
-          <a:solidFill>
-            <a:srgbClr val="B7791F"/>
-          </a:solidFill>
-          <a:ln>
-            <a:noFill/>
-          </a:ln>
-          <a:effectLst/>
-        </p:spPr>
-        <p:style>
-          <a:lnRef idx="1">
-            <a:schemeClr val="accent1"/>
-          </a:lnRef>
-          <a:fillRef idx="3">
-            <a:schemeClr val="accent1"/>
-          </a:fillRef>
-          <a:effectRef idx="2">
-            <a:schemeClr val="accent1"/>
-          </a:effectRef>
-          <a:fontRef idx="minor">
-            <a:schemeClr val="lt1"/>
-          </a:fontRef>
-        </p:style>
-        <p:txBody>
-          <a:bodyPr rtlCol="0" anchor="ctr"/>
-          <a:lstStyle/>
-          <a:p>
-            <a:pPr algn="ctr"/>
-          </a:p>
-        </p:txBody>
-      </p:sp>
-      <p:pic>
-        <p:nvPicPr>
-          <p:cNvPr id="18" name="Picture 17" descr="person.png"/>
-          <p:cNvPicPr>
-            <a:picLocks noChangeAspect="1"/>
-          </p:cNvPicPr>
-          <p:nvPr/>
-        </p:nvPicPr>
-        <p:blipFill>
-          <a:blip r:embed="rId3"/>
-          <a:stretch>
-            <a:fillRect/>
-          </a:stretch>
-        </p:blipFill>
-        <p:spPr>
-          <a:xfrm>
-            <a:off x="801014" y="3119018"/>
-            <a:ext cx="263348" cy="263348"/>
-          </a:xfrm>
-          <a:prstGeom prst="rect">
-            <a:avLst/>
-          </a:prstGeom>
-        </p:spPr>
-      </p:pic>
-      <p:sp>
-        <p:nvSpPr>
-          <p:cNvPr id="19" name="TextBox 18"/>
+          <p:cNvPr id="22" name="TextBox 21"/>
           <p:cNvSpPr txBox="1"/>
           <p:nvPr/>
         </p:nvSpPr>
         <p:spPr>
           <a:xfrm>
-            <a:off x="1417320" y="2962656"/>
-            <a:ext cx="10131552" cy="256032"/>
+            <a:off x="6281928" y="2459735"/>
+            <a:ext cx="265176" cy="219456"/>
           </a:xfrm>
           <a:prstGeom prst="rect">
             <a:avLst/>
@@ -4468,74 +4822,30 @@
               </a:spcAft>
             </a:pPr>
             <a:r>
-              <a:rPr sz="1250" b="1" i="0">
+              <a:rPr sz="980" b="1" i="0">
                 <a:solidFill>
                   <a:srgbClr val="16325C"/>
                 </a:solidFill>
                 <a:latin typeface="Calibri"/>
               </a:rPr>
-              <a:t>Hands-on setup</a:t>
-            </a:r>
-          </a:p>
-        </p:txBody>
-      </p:sp>
-      <p:sp>
-        <p:nvSpPr>
-          <p:cNvPr id="20" name="TextBox 19"/>
-          <p:cNvSpPr txBox="1"/>
-          <p:nvPr/>
-        </p:nvSpPr>
-        <p:spPr>
-          <a:xfrm>
-            <a:off x="1417320" y="3246120"/>
-            <a:ext cx="10131552" cy="365760"/>
-          </a:xfrm>
-          <a:prstGeom prst="rect">
-            <a:avLst/>
-          </a:prstGeom>
-          <a:noFill/>
-        </p:spPr>
-        <p:txBody>
-          <a:bodyPr wrap="square" anchor="t" lIns="0" rIns="0" tIns="0" bIns="0">
-            <a:spAutoFit/>
-          </a:bodyPr>
-          <a:lstStyle/>
-          <a:p>
-            <a:pPr algn="l">
-              <a:lnSpc>
-                <a:spcPct val="113000"/>
-              </a:lnSpc>
-              <a:spcAft>
-                <a:spcPts val="400"/>
-              </a:spcAft>
-            </a:pPr>
-            <a:r>
-              <a:rPr sz="1019" b="0" i="0">
-                <a:solidFill>
-                  <a:srgbClr val="3A4356"/>
-                </a:solidFill>
-                <a:latin typeface="Calibri"/>
-              </a:rPr>
-              <a:t>Material, process and machine are chosen by a person, part by part.</a:t>
-            </a:r>
-          </a:p>
-        </p:txBody>
-      </p:sp>
-      <p:sp>
-        <p:nvSpPr>
-          <p:cNvPr id="21" name="Rounded Rectangle 20"/>
+              <a:t>A</a:t>
+            </a:r>
+          </a:p>
+        </p:txBody>
+      </p:sp>
+      <p:sp>
+        <p:nvSpPr>
+          <p:cNvPr id="23" name="Rectangle 22"/>
           <p:cNvSpPr/>
           <p:nvPr/>
         </p:nvSpPr>
         <p:spPr>
           <a:xfrm>
-            <a:off x="411480" y="3749040"/>
-            <a:ext cx="11365992" cy="868680"/>
-          </a:xfrm>
-          <a:prstGeom prst="roundRect">
-            <a:avLst>
-              <a:gd name="adj" fmla="val 12000"/>
-            </a:avLst>
+            <a:off x="6611112" y="2395727"/>
+            <a:ext cx="3611880" cy="310896"/>
+          </a:xfrm>
+          <a:prstGeom prst="rect">
+            <a:avLst/>
           </a:prstGeom>
           <a:solidFill>
             <a:srgbClr val="FFFFFF"/>
@@ -4571,126 +4881,14 @@
       </p:sp>
       <p:sp>
         <p:nvSpPr>
-          <p:cNvPr id="22" name="Rectangle 21"/>
-          <p:cNvSpPr/>
-          <p:nvPr/>
-        </p:nvSpPr>
-        <p:spPr>
-          <a:xfrm>
-            <a:off x="411480" y="3749040"/>
-            <a:ext cx="68580" cy="868680"/>
-          </a:xfrm>
-          <a:prstGeom prst="rect">
-            <a:avLst/>
-          </a:prstGeom>
-          <a:solidFill>
-            <a:srgbClr val="B7791F"/>
-          </a:solidFill>
-          <a:ln>
-            <a:noFill/>
-          </a:ln>
-          <a:effectLst/>
-        </p:spPr>
-        <p:style>
-          <a:lnRef idx="1">
-            <a:schemeClr val="accent1"/>
-          </a:lnRef>
-          <a:fillRef idx="3">
-            <a:schemeClr val="accent1"/>
-          </a:fillRef>
-          <a:effectRef idx="2">
-            <a:schemeClr val="accent1"/>
-          </a:effectRef>
-          <a:fontRef idx="minor">
-            <a:schemeClr val="lt1"/>
-          </a:fontRef>
-        </p:style>
-        <p:txBody>
-          <a:bodyPr rtlCol="0" anchor="ctr"/>
-          <a:lstStyle/>
-          <a:p>
-            <a:pPr algn="ctr"/>
-          </a:p>
-        </p:txBody>
-      </p:sp>
-      <p:sp>
-        <p:nvSpPr>
-          <p:cNvPr id="23" name="Oval 22"/>
-          <p:cNvSpPr/>
-          <p:nvPr/>
-        </p:nvSpPr>
-        <p:spPr>
-          <a:xfrm>
-            <a:off x="658368" y="3909060"/>
-            <a:ext cx="548640" cy="548640"/>
-          </a:xfrm>
-          <a:prstGeom prst="ellipse">
-            <a:avLst/>
-          </a:prstGeom>
-          <a:solidFill>
-            <a:srgbClr val="B7791F"/>
-          </a:solidFill>
-          <a:ln>
-            <a:noFill/>
-          </a:ln>
-          <a:effectLst/>
-        </p:spPr>
-        <p:style>
-          <a:lnRef idx="1">
-            <a:schemeClr val="accent1"/>
-          </a:lnRef>
-          <a:fillRef idx="3">
-            <a:schemeClr val="accent1"/>
-          </a:fillRef>
-          <a:effectRef idx="2">
-            <a:schemeClr val="accent1"/>
-          </a:effectRef>
-          <a:fontRef idx="minor">
-            <a:schemeClr val="lt1"/>
-          </a:fontRef>
-        </p:style>
-        <p:txBody>
-          <a:bodyPr rtlCol="0" anchor="ctr"/>
-          <a:lstStyle/>
-          <a:p>
-            <a:pPr algn="ctr"/>
-          </a:p>
-        </p:txBody>
-      </p:sp>
-      <p:pic>
-        <p:nvPicPr>
-          <p:cNvPr id="24" name="Picture 23" descr="clip.png"/>
-          <p:cNvPicPr>
-            <a:picLocks noChangeAspect="1"/>
-          </p:cNvPicPr>
-          <p:nvPr/>
-        </p:nvPicPr>
-        <p:blipFill>
-          <a:blip r:embed="rId4"/>
-          <a:stretch>
-            <a:fillRect/>
-          </a:stretch>
-        </p:blipFill>
-        <p:spPr>
-          <a:xfrm>
-            <a:off x="801014" y="4051706"/>
-            <a:ext cx="263348" cy="263348"/>
-          </a:xfrm>
-          <a:prstGeom prst="rect">
-            <a:avLst/>
-          </a:prstGeom>
-        </p:spPr>
-      </p:pic>
-      <p:sp>
-        <p:nvSpPr>
-          <p:cNvPr id="25" name="TextBox 24"/>
+          <p:cNvPr id="24" name="TextBox 23"/>
           <p:cNvSpPr txBox="1"/>
           <p:nvPr/>
         </p:nvSpPr>
         <p:spPr>
           <a:xfrm>
-            <a:off x="1417320" y="3895344"/>
-            <a:ext cx="10131552" cy="256032"/>
+            <a:off x="6693408" y="2459735"/>
+            <a:ext cx="3465576" cy="219456"/>
           </a:xfrm>
           <a:prstGeom prst="rect">
             <a:avLst/>
@@ -4712,74 +4910,30 @@
               </a:spcAft>
             </a:pPr>
             <a:r>
-              <a:rPr sz="1250" b="1" i="0">
-                <a:solidFill>
-                  <a:srgbClr val="16325C"/>
+              <a:rPr sz="980" b="0" i="0">
+                <a:solidFill>
+                  <a:srgbClr val="3A4356"/>
                 </a:solidFill>
                 <a:latin typeface="Calibri"/>
               </a:rPr>
-              <a:t>Manual data entry</a:t>
-            </a:r>
-          </a:p>
-        </p:txBody>
-      </p:sp>
-      <p:sp>
-        <p:nvSpPr>
-          <p:cNvPr id="26" name="TextBox 25"/>
-          <p:cNvSpPr txBox="1"/>
-          <p:nvPr/>
-        </p:nvSpPr>
-        <p:spPr>
-          <a:xfrm>
-            <a:off x="1417320" y="4178808"/>
-            <a:ext cx="10131552" cy="365760"/>
-          </a:xfrm>
-          <a:prstGeom prst="rect">
-            <a:avLst/>
-          </a:prstGeom>
-          <a:noFill/>
-        </p:spPr>
-        <p:txBody>
-          <a:bodyPr wrap="square" anchor="t" lIns="0" rIns="0" tIns="0" bIns="0">
-            <a:spAutoFit/>
-          </a:bodyPr>
-          <a:lstStyle/>
-          <a:p>
-            <a:pPr algn="l">
-              <a:lnSpc>
-                <a:spcPct val="113000"/>
-              </a:lnSpc>
-              <a:spcAft>
-                <a:spcPts val="400"/>
-              </a:spcAft>
-            </a:pPr>
-            <a:r>
-              <a:rPr sz="1019" b="0" i="0">
-                <a:solidFill>
-                  <a:srgbClr val="3A4356"/>
-                </a:solidFill>
-                <a:latin typeface="Calibri"/>
-              </a:rPr>
-              <a:t>Geometry and tolerances are read off the 3D model and the drawing, then typed in.</a:t>
-            </a:r>
-          </a:p>
-        </p:txBody>
-      </p:sp>
-      <p:sp>
-        <p:nvSpPr>
-          <p:cNvPr id="27" name="Rounded Rectangle 26"/>
+              <a:t>Minutes to cost one part today</a:t>
+            </a:r>
+          </a:p>
+        </p:txBody>
+      </p:sp>
+      <p:sp>
+        <p:nvSpPr>
+          <p:cNvPr id="25" name="Rectangle 24"/>
           <p:cNvSpPr/>
           <p:nvPr/>
         </p:nvSpPr>
         <p:spPr>
           <a:xfrm>
-            <a:off x="411480" y="4681728"/>
-            <a:ext cx="11365992" cy="868680"/>
-          </a:xfrm>
-          <a:prstGeom prst="roundRect">
-            <a:avLst>
-              <a:gd name="adj" fmla="val 12000"/>
-            </a:avLst>
+            <a:off x="10222992" y="2395727"/>
+            <a:ext cx="1554480" cy="310896"/>
+          </a:xfrm>
+          <a:prstGeom prst="rect">
+            <a:avLst/>
           </a:prstGeom>
           <a:solidFill>
             <a:srgbClr val="FFFFFF"/>
@@ -4815,126 +4969,14 @@
       </p:sp>
       <p:sp>
         <p:nvSpPr>
-          <p:cNvPr id="28" name="Rectangle 27"/>
-          <p:cNvSpPr/>
-          <p:nvPr/>
-        </p:nvSpPr>
-        <p:spPr>
-          <a:xfrm>
-            <a:off x="411480" y="4681728"/>
-            <a:ext cx="68580" cy="868680"/>
-          </a:xfrm>
-          <a:prstGeom prst="rect">
-            <a:avLst/>
-          </a:prstGeom>
-          <a:solidFill>
-            <a:srgbClr val="B7791F"/>
-          </a:solidFill>
-          <a:ln>
-            <a:noFill/>
-          </a:ln>
-          <a:effectLst/>
-        </p:spPr>
-        <p:style>
-          <a:lnRef idx="1">
-            <a:schemeClr val="accent1"/>
-          </a:lnRef>
-          <a:fillRef idx="3">
-            <a:schemeClr val="accent1"/>
-          </a:fillRef>
-          <a:effectRef idx="2">
-            <a:schemeClr val="accent1"/>
-          </a:effectRef>
-          <a:fontRef idx="minor">
-            <a:schemeClr val="lt1"/>
-          </a:fontRef>
-        </p:style>
-        <p:txBody>
-          <a:bodyPr rtlCol="0" anchor="ctr"/>
-          <a:lstStyle/>
-          <a:p>
-            <a:pPr algn="ctr"/>
-          </a:p>
-        </p:txBody>
-      </p:sp>
-      <p:sp>
-        <p:nvSpPr>
-          <p:cNvPr id="29" name="Oval 28"/>
-          <p:cNvSpPr/>
-          <p:nvPr/>
-        </p:nvSpPr>
-        <p:spPr>
-          <a:xfrm>
-            <a:off x="658368" y="4841748"/>
-            <a:ext cx="548640" cy="548640"/>
-          </a:xfrm>
-          <a:prstGeom prst="ellipse">
-            <a:avLst/>
-          </a:prstGeom>
-          <a:solidFill>
-            <a:srgbClr val="B7791F"/>
-          </a:solidFill>
-          <a:ln>
-            <a:noFill/>
-          </a:ln>
-          <a:effectLst/>
-        </p:spPr>
-        <p:style>
-          <a:lnRef idx="1">
-            <a:schemeClr val="accent1"/>
-          </a:lnRef>
-          <a:fillRef idx="3">
-            <a:schemeClr val="accent1"/>
-          </a:fillRef>
-          <a:effectRef idx="2">
-            <a:schemeClr val="accent1"/>
-          </a:effectRef>
-          <a:fontRef idx="minor">
-            <a:schemeClr val="lt1"/>
-          </a:fontRef>
-        </p:style>
-        <p:txBody>
-          <a:bodyPr rtlCol="0" anchor="ctr"/>
-          <a:lstStyle/>
-          <a:p>
-            <a:pPr algn="ctr"/>
-          </a:p>
-        </p:txBody>
-      </p:sp>
-      <p:pic>
-        <p:nvPicPr>
-          <p:cNvPr id="30" name="Picture 29" descr="clock.png"/>
-          <p:cNvPicPr>
-            <a:picLocks noChangeAspect="1"/>
-          </p:cNvPicPr>
-          <p:nvPr/>
-        </p:nvPicPr>
-        <p:blipFill>
-          <a:blip r:embed="rId5"/>
-          <a:stretch>
-            <a:fillRect/>
-          </a:stretch>
-        </p:blipFill>
-        <p:spPr>
-          <a:xfrm>
-            <a:off x="801014" y="4984394"/>
-            <a:ext cx="263348" cy="263348"/>
-          </a:xfrm>
-          <a:prstGeom prst="rect">
-            <a:avLst/>
-          </a:prstGeom>
-        </p:spPr>
-      </p:pic>
-      <p:sp>
-        <p:nvSpPr>
-          <p:cNvPr id="31" name="TextBox 30"/>
+          <p:cNvPr id="26" name="TextBox 25"/>
           <p:cNvSpPr txBox="1"/>
           <p:nvPr/>
         </p:nvSpPr>
         <p:spPr>
           <a:xfrm>
-            <a:off x="1417320" y="4828032"/>
-            <a:ext cx="10131552" cy="256032"/>
+            <a:off x="10305288" y="2459735"/>
+            <a:ext cx="1408176" cy="219456"/>
           </a:xfrm>
           <a:prstGeom prst="rect">
             <a:avLst/>
@@ -4956,80 +4998,38 @@
               </a:spcAft>
             </a:pPr>
             <a:r>
-              <a:rPr sz="1250" b="1" i="0">
-                <a:solidFill>
-                  <a:srgbClr val="16325C"/>
+              <a:rPr sz="980" b="1" i="0">
+                <a:solidFill>
+                  <a:srgbClr val="1D6FB8"/>
                 </a:solidFill>
                 <a:latin typeface="Calibri"/>
               </a:rPr>
-              <a:t>Updated by hand</a:t>
-            </a:r>
-          </a:p>
-        </p:txBody>
-      </p:sp>
-      <p:sp>
-        <p:nvSpPr>
-          <p:cNvPr id="32" name="TextBox 31"/>
-          <p:cNvSpPr txBox="1"/>
-          <p:nvPr/>
-        </p:nvSpPr>
-        <p:spPr>
-          <a:xfrm>
-            <a:off x="1417320" y="5111496"/>
-            <a:ext cx="10131552" cy="365760"/>
-          </a:xfrm>
-          <a:prstGeom prst="rect">
-            <a:avLst/>
-          </a:prstGeom>
-          <a:noFill/>
-        </p:spPr>
-        <p:txBody>
-          <a:bodyPr wrap="square" anchor="t" lIns="0" rIns="0" tIns="0" bIns="0">
-            <a:spAutoFit/>
-          </a:bodyPr>
-          <a:lstStyle/>
-          <a:p>
-            <a:pPr algn="l">
-              <a:lnSpc>
-                <a:spcPct val="113000"/>
-              </a:lnSpc>
-              <a:spcAft>
-                <a:spcPts val="400"/>
-              </a:spcAft>
-            </a:pPr>
-            <a:r>
-              <a:rPr sz="1019" b="0" i="0">
-                <a:solidFill>
-                  <a:srgbClr val="3A4356"/>
-                </a:solidFill>
-                <a:latin typeface="Calibri"/>
-              </a:rPr>
-              <a:t>Rates and inputs are refreshed manually as the economics move.</a:t>
-            </a:r>
-          </a:p>
-        </p:txBody>
-      </p:sp>
-      <p:sp>
-        <p:nvSpPr>
-          <p:cNvPr id="33" name="Rounded Rectangle 32"/>
+              <a:t>________</a:t>
+            </a:r>
+          </a:p>
+        </p:txBody>
+      </p:sp>
+      <p:sp>
+        <p:nvSpPr>
+          <p:cNvPr id="27" name="Rectangle 26"/>
           <p:cNvSpPr/>
           <p:nvPr/>
         </p:nvSpPr>
         <p:spPr>
           <a:xfrm>
-            <a:off x="411480" y="5669280"/>
-            <a:ext cx="11365992" cy="914400"/>
-          </a:xfrm>
-          <a:prstGeom prst="roundRect">
-            <a:avLst>
-              <a:gd name="adj" fmla="val 12000"/>
-            </a:avLst>
+            <a:off x="6199632" y="2706623"/>
+            <a:ext cx="411480" cy="310896"/>
+          </a:xfrm>
+          <a:prstGeom prst="rect">
+            <a:avLst/>
           </a:prstGeom>
           <a:solidFill>
-            <a:srgbClr val="EAF6EF"/>
+            <a:srgbClr val="F4F7FB"/>
           </a:solidFill>
-          <a:ln>
-            <a:noFill/>
+          <a:ln w="9525">
+            <a:solidFill>
+              <a:srgbClr val="DCE3EE"/>
+            </a:solidFill>
           </a:ln>
           <a:effectLst/>
         </p:spPr>
@@ -5057,58 +5057,14 @@
       </p:sp>
       <p:sp>
         <p:nvSpPr>
-          <p:cNvPr id="34" name="Rectangle 33"/>
-          <p:cNvSpPr/>
-          <p:nvPr/>
-        </p:nvSpPr>
-        <p:spPr>
-          <a:xfrm>
-            <a:off x="411480" y="5669280"/>
-            <a:ext cx="68580" cy="914400"/>
-          </a:xfrm>
-          <a:prstGeom prst="rect">
-            <a:avLst/>
-          </a:prstGeom>
-          <a:solidFill>
-            <a:srgbClr val="2E8B57"/>
-          </a:solidFill>
-          <a:ln>
-            <a:noFill/>
-          </a:ln>
-          <a:effectLst/>
-        </p:spPr>
-        <p:style>
-          <a:lnRef idx="1">
-            <a:schemeClr val="accent1"/>
-          </a:lnRef>
-          <a:fillRef idx="3">
-            <a:schemeClr val="accent1"/>
-          </a:fillRef>
-          <a:effectRef idx="2">
-            <a:schemeClr val="accent1"/>
-          </a:effectRef>
-          <a:fontRef idx="minor">
-            <a:schemeClr val="lt1"/>
-          </a:fontRef>
-        </p:style>
-        <p:txBody>
-          <a:bodyPr rtlCol="0" anchor="ctr"/>
-          <a:lstStyle/>
-          <a:p>
-            <a:pPr algn="ctr"/>
-          </a:p>
-        </p:txBody>
-      </p:sp>
-      <p:sp>
-        <p:nvSpPr>
-          <p:cNvPr id="35" name="TextBox 34"/>
+          <p:cNvPr id="28" name="TextBox 27"/>
           <p:cNvSpPr txBox="1"/>
           <p:nvPr/>
         </p:nvSpPr>
         <p:spPr>
           <a:xfrm>
-            <a:off x="630936" y="5788152"/>
-            <a:ext cx="10954512" cy="256032"/>
+            <a:off x="6281928" y="2770631"/>
+            <a:ext cx="265176" cy="219456"/>
           </a:xfrm>
           <a:prstGeom prst="rect">
             <a:avLst/>
@@ -5130,6 +5086,1634 @@
               </a:spcAft>
             </a:pPr>
             <a:r>
+              <a:rPr sz="980" b="1" i="0">
+                <a:solidFill>
+                  <a:srgbClr val="16325C"/>
+                </a:solidFill>
+                <a:latin typeface="Calibri"/>
+              </a:rPr>
+              <a:t>B</a:t>
+            </a:r>
+          </a:p>
+        </p:txBody>
+      </p:sp>
+      <p:sp>
+        <p:nvSpPr>
+          <p:cNvPr id="29" name="Rectangle 28"/>
+          <p:cNvSpPr/>
+          <p:nvPr/>
+        </p:nvSpPr>
+        <p:spPr>
+          <a:xfrm>
+            <a:off x="6611112" y="2706623"/>
+            <a:ext cx="3611880" cy="310896"/>
+          </a:xfrm>
+          <a:prstGeom prst="rect">
+            <a:avLst/>
+          </a:prstGeom>
+          <a:solidFill>
+            <a:srgbClr val="F4F7FB"/>
+          </a:solidFill>
+          <a:ln w="9525">
+            <a:solidFill>
+              <a:srgbClr val="DCE3EE"/>
+            </a:solidFill>
+          </a:ln>
+          <a:effectLst/>
+        </p:spPr>
+        <p:style>
+          <a:lnRef idx="1">
+            <a:schemeClr val="accent1"/>
+          </a:lnRef>
+          <a:fillRef idx="3">
+            <a:schemeClr val="accent1"/>
+          </a:fillRef>
+          <a:effectRef idx="2">
+            <a:schemeClr val="accent1"/>
+          </a:effectRef>
+          <a:fontRef idx="minor">
+            <a:schemeClr val="lt1"/>
+          </a:fontRef>
+        </p:style>
+        <p:txBody>
+          <a:bodyPr rtlCol="0" anchor="ctr"/>
+          <a:lstStyle/>
+          <a:p>
+            <a:pPr algn="ctr"/>
+          </a:p>
+        </p:txBody>
+      </p:sp>
+      <p:sp>
+        <p:nvSpPr>
+          <p:cNvPr id="30" name="TextBox 29"/>
+          <p:cNvSpPr txBox="1"/>
+          <p:nvPr/>
+        </p:nvSpPr>
+        <p:spPr>
+          <a:xfrm>
+            <a:off x="6693408" y="2770631"/>
+            <a:ext cx="3465576" cy="219456"/>
+          </a:xfrm>
+          <a:prstGeom prst="rect">
+            <a:avLst/>
+          </a:prstGeom>
+          <a:noFill/>
+        </p:spPr>
+        <p:txBody>
+          <a:bodyPr wrap="square" anchor="t" lIns="0" rIns="0" tIns="0" bIns="0">
+            <a:spAutoFit/>
+          </a:bodyPr>
+          <a:lstStyle/>
+          <a:p>
+            <a:pPr algn="l">
+              <a:lnSpc>
+                <a:spcPct val="100000"/>
+              </a:lnSpc>
+              <a:spcAft>
+                <a:spcPts val="400"/>
+              </a:spcAft>
+            </a:pPr>
+            <a:r>
+              <a:rPr sz="980" b="0" i="0">
+                <a:solidFill>
+                  <a:srgbClr val="3A4356"/>
+                </a:solidFill>
+                <a:latin typeface="Calibri"/>
+              </a:rPr>
+              <a:t>Of those, minutes reading the model and typing</a:t>
+            </a:r>
+          </a:p>
+        </p:txBody>
+      </p:sp>
+      <p:sp>
+        <p:nvSpPr>
+          <p:cNvPr id="31" name="Rectangle 30"/>
+          <p:cNvSpPr/>
+          <p:nvPr/>
+        </p:nvSpPr>
+        <p:spPr>
+          <a:xfrm>
+            <a:off x="10222992" y="2706623"/>
+            <a:ext cx="1554480" cy="310896"/>
+          </a:xfrm>
+          <a:prstGeom prst="rect">
+            <a:avLst/>
+          </a:prstGeom>
+          <a:solidFill>
+            <a:srgbClr val="F4F7FB"/>
+          </a:solidFill>
+          <a:ln w="9525">
+            <a:solidFill>
+              <a:srgbClr val="DCE3EE"/>
+            </a:solidFill>
+          </a:ln>
+          <a:effectLst/>
+        </p:spPr>
+        <p:style>
+          <a:lnRef idx="1">
+            <a:schemeClr val="accent1"/>
+          </a:lnRef>
+          <a:fillRef idx="3">
+            <a:schemeClr val="accent1"/>
+          </a:fillRef>
+          <a:effectRef idx="2">
+            <a:schemeClr val="accent1"/>
+          </a:effectRef>
+          <a:fontRef idx="minor">
+            <a:schemeClr val="lt1"/>
+          </a:fontRef>
+        </p:style>
+        <p:txBody>
+          <a:bodyPr rtlCol="0" anchor="ctr"/>
+          <a:lstStyle/>
+          <a:p>
+            <a:pPr algn="ctr"/>
+          </a:p>
+        </p:txBody>
+      </p:sp>
+      <p:sp>
+        <p:nvSpPr>
+          <p:cNvPr id="32" name="TextBox 31"/>
+          <p:cNvSpPr txBox="1"/>
+          <p:nvPr/>
+        </p:nvSpPr>
+        <p:spPr>
+          <a:xfrm>
+            <a:off x="10305288" y="2770631"/>
+            <a:ext cx="1408176" cy="219456"/>
+          </a:xfrm>
+          <a:prstGeom prst="rect">
+            <a:avLst/>
+          </a:prstGeom>
+          <a:noFill/>
+        </p:spPr>
+        <p:txBody>
+          <a:bodyPr wrap="square" anchor="t" lIns="0" rIns="0" tIns="0" bIns="0">
+            <a:spAutoFit/>
+          </a:bodyPr>
+          <a:lstStyle/>
+          <a:p>
+            <a:pPr algn="l">
+              <a:lnSpc>
+                <a:spcPct val="100000"/>
+              </a:lnSpc>
+              <a:spcAft>
+                <a:spcPts val="400"/>
+              </a:spcAft>
+            </a:pPr>
+            <a:r>
+              <a:rPr sz="980" b="1" i="0">
+                <a:solidFill>
+                  <a:srgbClr val="1D6FB8"/>
+                </a:solidFill>
+                <a:latin typeface="Calibri"/>
+              </a:rPr>
+              <a:t>________</a:t>
+            </a:r>
+          </a:p>
+        </p:txBody>
+      </p:sp>
+      <p:sp>
+        <p:nvSpPr>
+          <p:cNvPr id="33" name="Rectangle 32"/>
+          <p:cNvSpPr/>
+          <p:nvPr/>
+        </p:nvSpPr>
+        <p:spPr>
+          <a:xfrm>
+            <a:off x="6199632" y="3017519"/>
+            <a:ext cx="411480" cy="310896"/>
+          </a:xfrm>
+          <a:prstGeom prst="rect">
+            <a:avLst/>
+          </a:prstGeom>
+          <a:solidFill>
+            <a:srgbClr val="FFFFFF"/>
+          </a:solidFill>
+          <a:ln w="9525">
+            <a:solidFill>
+              <a:srgbClr val="DCE3EE"/>
+            </a:solidFill>
+          </a:ln>
+          <a:effectLst/>
+        </p:spPr>
+        <p:style>
+          <a:lnRef idx="1">
+            <a:schemeClr val="accent1"/>
+          </a:lnRef>
+          <a:fillRef idx="3">
+            <a:schemeClr val="accent1"/>
+          </a:fillRef>
+          <a:effectRef idx="2">
+            <a:schemeClr val="accent1"/>
+          </a:effectRef>
+          <a:fontRef idx="minor">
+            <a:schemeClr val="lt1"/>
+          </a:fontRef>
+        </p:style>
+        <p:txBody>
+          <a:bodyPr rtlCol="0" anchor="ctr"/>
+          <a:lstStyle/>
+          <a:p>
+            <a:pPr algn="ctr"/>
+          </a:p>
+        </p:txBody>
+      </p:sp>
+      <p:sp>
+        <p:nvSpPr>
+          <p:cNvPr id="34" name="TextBox 33"/>
+          <p:cNvSpPr txBox="1"/>
+          <p:nvPr/>
+        </p:nvSpPr>
+        <p:spPr>
+          <a:xfrm>
+            <a:off x="6281928" y="3081527"/>
+            <a:ext cx="265176" cy="219456"/>
+          </a:xfrm>
+          <a:prstGeom prst="rect">
+            <a:avLst/>
+          </a:prstGeom>
+          <a:noFill/>
+        </p:spPr>
+        <p:txBody>
+          <a:bodyPr wrap="square" anchor="t" lIns="0" rIns="0" tIns="0" bIns="0">
+            <a:spAutoFit/>
+          </a:bodyPr>
+          <a:lstStyle/>
+          <a:p>
+            <a:pPr algn="l">
+              <a:lnSpc>
+                <a:spcPct val="100000"/>
+              </a:lnSpc>
+              <a:spcAft>
+                <a:spcPts val="400"/>
+              </a:spcAft>
+            </a:pPr>
+            <a:r>
+              <a:rPr sz="980" b="1" i="0">
+                <a:solidFill>
+                  <a:srgbClr val="16325C"/>
+                </a:solidFill>
+                <a:latin typeface="Calibri"/>
+              </a:rPr>
+              <a:t>C</a:t>
+            </a:r>
+          </a:p>
+        </p:txBody>
+      </p:sp>
+      <p:sp>
+        <p:nvSpPr>
+          <p:cNvPr id="35" name="Rectangle 34"/>
+          <p:cNvSpPr/>
+          <p:nvPr/>
+        </p:nvSpPr>
+        <p:spPr>
+          <a:xfrm>
+            <a:off x="6611112" y="3017519"/>
+            <a:ext cx="3611880" cy="310896"/>
+          </a:xfrm>
+          <a:prstGeom prst="rect">
+            <a:avLst/>
+          </a:prstGeom>
+          <a:solidFill>
+            <a:srgbClr val="FFFFFF"/>
+          </a:solidFill>
+          <a:ln w="9525">
+            <a:solidFill>
+              <a:srgbClr val="DCE3EE"/>
+            </a:solidFill>
+          </a:ln>
+          <a:effectLst/>
+        </p:spPr>
+        <p:style>
+          <a:lnRef idx="1">
+            <a:schemeClr val="accent1"/>
+          </a:lnRef>
+          <a:fillRef idx="3">
+            <a:schemeClr val="accent1"/>
+          </a:fillRef>
+          <a:effectRef idx="2">
+            <a:schemeClr val="accent1"/>
+          </a:effectRef>
+          <a:fontRef idx="minor">
+            <a:schemeClr val="lt1"/>
+          </a:fontRef>
+        </p:style>
+        <p:txBody>
+          <a:bodyPr rtlCol="0" anchor="ctr"/>
+          <a:lstStyle/>
+          <a:p>
+            <a:pPr algn="ctr"/>
+          </a:p>
+        </p:txBody>
+      </p:sp>
+      <p:sp>
+        <p:nvSpPr>
+          <p:cNvPr id="36" name="TextBox 35"/>
+          <p:cNvSpPr txBox="1"/>
+          <p:nvPr/>
+        </p:nvSpPr>
+        <p:spPr>
+          <a:xfrm>
+            <a:off x="6693408" y="3081527"/>
+            <a:ext cx="3465576" cy="219456"/>
+          </a:xfrm>
+          <a:prstGeom prst="rect">
+            <a:avLst/>
+          </a:prstGeom>
+          <a:noFill/>
+        </p:spPr>
+        <p:txBody>
+          <a:bodyPr wrap="square" anchor="t" lIns="0" rIns="0" tIns="0" bIns="0">
+            <a:spAutoFit/>
+          </a:bodyPr>
+          <a:lstStyle/>
+          <a:p>
+            <a:pPr algn="l">
+              <a:lnSpc>
+                <a:spcPct val="100000"/>
+              </a:lnSpc>
+              <a:spcAft>
+                <a:spcPts val="400"/>
+              </a:spcAft>
+            </a:pPr>
+            <a:r>
+              <a:rPr sz="980" b="0" i="0">
+                <a:solidFill>
+                  <a:srgbClr val="3A4356"/>
+                </a:solidFill>
+                <a:latin typeface="Calibri"/>
+              </a:rPr>
+              <a:t>Parts we cost in a year</a:t>
+            </a:r>
+          </a:p>
+        </p:txBody>
+      </p:sp>
+      <p:sp>
+        <p:nvSpPr>
+          <p:cNvPr id="37" name="Rectangle 36"/>
+          <p:cNvSpPr/>
+          <p:nvPr/>
+        </p:nvSpPr>
+        <p:spPr>
+          <a:xfrm>
+            <a:off x="10222992" y="3017519"/>
+            <a:ext cx="1554480" cy="310896"/>
+          </a:xfrm>
+          <a:prstGeom prst="rect">
+            <a:avLst/>
+          </a:prstGeom>
+          <a:solidFill>
+            <a:srgbClr val="FFFFFF"/>
+          </a:solidFill>
+          <a:ln w="9525">
+            <a:solidFill>
+              <a:srgbClr val="DCE3EE"/>
+            </a:solidFill>
+          </a:ln>
+          <a:effectLst/>
+        </p:spPr>
+        <p:style>
+          <a:lnRef idx="1">
+            <a:schemeClr val="accent1"/>
+          </a:lnRef>
+          <a:fillRef idx="3">
+            <a:schemeClr val="accent1"/>
+          </a:fillRef>
+          <a:effectRef idx="2">
+            <a:schemeClr val="accent1"/>
+          </a:effectRef>
+          <a:fontRef idx="minor">
+            <a:schemeClr val="lt1"/>
+          </a:fontRef>
+        </p:style>
+        <p:txBody>
+          <a:bodyPr rtlCol="0" anchor="ctr"/>
+          <a:lstStyle/>
+          <a:p>
+            <a:pPr algn="ctr"/>
+          </a:p>
+        </p:txBody>
+      </p:sp>
+      <p:sp>
+        <p:nvSpPr>
+          <p:cNvPr id="38" name="TextBox 37"/>
+          <p:cNvSpPr txBox="1"/>
+          <p:nvPr/>
+        </p:nvSpPr>
+        <p:spPr>
+          <a:xfrm>
+            <a:off x="10305288" y="3081527"/>
+            <a:ext cx="1408176" cy="219456"/>
+          </a:xfrm>
+          <a:prstGeom prst="rect">
+            <a:avLst/>
+          </a:prstGeom>
+          <a:noFill/>
+        </p:spPr>
+        <p:txBody>
+          <a:bodyPr wrap="square" anchor="t" lIns="0" rIns="0" tIns="0" bIns="0">
+            <a:spAutoFit/>
+          </a:bodyPr>
+          <a:lstStyle/>
+          <a:p>
+            <a:pPr algn="l">
+              <a:lnSpc>
+                <a:spcPct val="100000"/>
+              </a:lnSpc>
+              <a:spcAft>
+                <a:spcPts val="400"/>
+              </a:spcAft>
+            </a:pPr>
+            <a:r>
+              <a:rPr sz="980" b="1" i="0">
+                <a:solidFill>
+                  <a:srgbClr val="1D6FB8"/>
+                </a:solidFill>
+                <a:latin typeface="Calibri"/>
+              </a:rPr>
+              <a:t>________</a:t>
+            </a:r>
+          </a:p>
+        </p:txBody>
+      </p:sp>
+      <p:sp>
+        <p:nvSpPr>
+          <p:cNvPr id="39" name="Rectangle 38"/>
+          <p:cNvSpPr/>
+          <p:nvPr/>
+        </p:nvSpPr>
+        <p:spPr>
+          <a:xfrm>
+            <a:off x="6199632" y="3328415"/>
+            <a:ext cx="411480" cy="310896"/>
+          </a:xfrm>
+          <a:prstGeom prst="rect">
+            <a:avLst/>
+          </a:prstGeom>
+          <a:solidFill>
+            <a:srgbClr val="F4F7FB"/>
+          </a:solidFill>
+          <a:ln w="9525">
+            <a:solidFill>
+              <a:srgbClr val="DCE3EE"/>
+            </a:solidFill>
+          </a:ln>
+          <a:effectLst/>
+        </p:spPr>
+        <p:style>
+          <a:lnRef idx="1">
+            <a:schemeClr val="accent1"/>
+          </a:lnRef>
+          <a:fillRef idx="3">
+            <a:schemeClr val="accent1"/>
+          </a:fillRef>
+          <a:effectRef idx="2">
+            <a:schemeClr val="accent1"/>
+          </a:effectRef>
+          <a:fontRef idx="minor">
+            <a:schemeClr val="lt1"/>
+          </a:fontRef>
+        </p:style>
+        <p:txBody>
+          <a:bodyPr rtlCol="0" anchor="ctr"/>
+          <a:lstStyle/>
+          <a:p>
+            <a:pPr algn="ctr"/>
+          </a:p>
+        </p:txBody>
+      </p:sp>
+      <p:sp>
+        <p:nvSpPr>
+          <p:cNvPr id="40" name="TextBox 39"/>
+          <p:cNvSpPr txBox="1"/>
+          <p:nvPr/>
+        </p:nvSpPr>
+        <p:spPr>
+          <a:xfrm>
+            <a:off x="6281928" y="3392423"/>
+            <a:ext cx="265176" cy="219456"/>
+          </a:xfrm>
+          <a:prstGeom prst="rect">
+            <a:avLst/>
+          </a:prstGeom>
+          <a:noFill/>
+        </p:spPr>
+        <p:txBody>
+          <a:bodyPr wrap="square" anchor="t" lIns="0" rIns="0" tIns="0" bIns="0">
+            <a:spAutoFit/>
+          </a:bodyPr>
+          <a:lstStyle/>
+          <a:p>
+            <a:pPr algn="l">
+              <a:lnSpc>
+                <a:spcPct val="100000"/>
+              </a:lnSpc>
+              <a:spcAft>
+                <a:spcPts val="400"/>
+              </a:spcAft>
+            </a:pPr>
+            <a:r>
+              <a:rPr sz="980" b="1" i="0">
+                <a:solidFill>
+                  <a:srgbClr val="16325C"/>
+                </a:solidFill>
+                <a:latin typeface="Calibri"/>
+              </a:rPr>
+              <a:t>D</a:t>
+            </a:r>
+          </a:p>
+        </p:txBody>
+      </p:sp>
+      <p:sp>
+        <p:nvSpPr>
+          <p:cNvPr id="41" name="Rectangle 40"/>
+          <p:cNvSpPr/>
+          <p:nvPr/>
+        </p:nvSpPr>
+        <p:spPr>
+          <a:xfrm>
+            <a:off x="6611112" y="3328415"/>
+            <a:ext cx="3611880" cy="310896"/>
+          </a:xfrm>
+          <a:prstGeom prst="rect">
+            <a:avLst/>
+          </a:prstGeom>
+          <a:solidFill>
+            <a:srgbClr val="F4F7FB"/>
+          </a:solidFill>
+          <a:ln w="9525">
+            <a:solidFill>
+              <a:srgbClr val="DCE3EE"/>
+            </a:solidFill>
+          </a:ln>
+          <a:effectLst/>
+        </p:spPr>
+        <p:style>
+          <a:lnRef idx="1">
+            <a:schemeClr val="accent1"/>
+          </a:lnRef>
+          <a:fillRef idx="3">
+            <a:schemeClr val="accent1"/>
+          </a:fillRef>
+          <a:effectRef idx="2">
+            <a:schemeClr val="accent1"/>
+          </a:effectRef>
+          <a:fontRef idx="minor">
+            <a:schemeClr val="lt1"/>
+          </a:fontRef>
+        </p:style>
+        <p:txBody>
+          <a:bodyPr rtlCol="0" anchor="ctr"/>
+          <a:lstStyle/>
+          <a:p>
+            <a:pPr algn="ctr"/>
+          </a:p>
+        </p:txBody>
+      </p:sp>
+      <p:sp>
+        <p:nvSpPr>
+          <p:cNvPr id="42" name="TextBox 41"/>
+          <p:cNvSpPr txBox="1"/>
+          <p:nvPr/>
+        </p:nvSpPr>
+        <p:spPr>
+          <a:xfrm>
+            <a:off x="6693408" y="3392423"/>
+            <a:ext cx="3465576" cy="219456"/>
+          </a:xfrm>
+          <a:prstGeom prst="rect">
+            <a:avLst/>
+          </a:prstGeom>
+          <a:noFill/>
+        </p:spPr>
+        <p:txBody>
+          <a:bodyPr wrap="square" anchor="t" lIns="0" rIns="0" tIns="0" bIns="0">
+            <a:spAutoFit/>
+          </a:bodyPr>
+          <a:lstStyle/>
+          <a:p>
+            <a:pPr algn="l">
+              <a:lnSpc>
+                <a:spcPct val="100000"/>
+              </a:lnSpc>
+              <a:spcAft>
+                <a:spcPts val="400"/>
+              </a:spcAft>
+            </a:pPr>
+            <a:r>
+              <a:rPr sz="980" b="0" i="0">
+                <a:solidFill>
+                  <a:srgbClr val="3A4356"/>
+                </a:solidFill>
+                <a:latin typeface="Calibri"/>
+              </a:rPr>
+              <a:t>Parts in a basket we never cost individually</a:t>
+            </a:r>
+          </a:p>
+        </p:txBody>
+      </p:sp>
+      <p:sp>
+        <p:nvSpPr>
+          <p:cNvPr id="43" name="Rectangle 42"/>
+          <p:cNvSpPr/>
+          <p:nvPr/>
+        </p:nvSpPr>
+        <p:spPr>
+          <a:xfrm>
+            <a:off x="10222992" y="3328415"/>
+            <a:ext cx="1554480" cy="310896"/>
+          </a:xfrm>
+          <a:prstGeom prst="rect">
+            <a:avLst/>
+          </a:prstGeom>
+          <a:solidFill>
+            <a:srgbClr val="F4F7FB"/>
+          </a:solidFill>
+          <a:ln w="9525">
+            <a:solidFill>
+              <a:srgbClr val="DCE3EE"/>
+            </a:solidFill>
+          </a:ln>
+          <a:effectLst/>
+        </p:spPr>
+        <p:style>
+          <a:lnRef idx="1">
+            <a:schemeClr val="accent1"/>
+          </a:lnRef>
+          <a:fillRef idx="3">
+            <a:schemeClr val="accent1"/>
+          </a:fillRef>
+          <a:effectRef idx="2">
+            <a:schemeClr val="accent1"/>
+          </a:effectRef>
+          <a:fontRef idx="minor">
+            <a:schemeClr val="lt1"/>
+          </a:fontRef>
+        </p:style>
+        <p:txBody>
+          <a:bodyPr rtlCol="0" anchor="ctr"/>
+          <a:lstStyle/>
+          <a:p>
+            <a:pPr algn="ctr"/>
+          </a:p>
+        </p:txBody>
+      </p:sp>
+      <p:sp>
+        <p:nvSpPr>
+          <p:cNvPr id="44" name="TextBox 43"/>
+          <p:cNvSpPr txBox="1"/>
+          <p:nvPr/>
+        </p:nvSpPr>
+        <p:spPr>
+          <a:xfrm>
+            <a:off x="10305288" y="3392423"/>
+            <a:ext cx="1408176" cy="219456"/>
+          </a:xfrm>
+          <a:prstGeom prst="rect">
+            <a:avLst/>
+          </a:prstGeom>
+          <a:noFill/>
+        </p:spPr>
+        <p:txBody>
+          <a:bodyPr wrap="square" anchor="t" lIns="0" rIns="0" tIns="0" bIns="0">
+            <a:spAutoFit/>
+          </a:bodyPr>
+          <a:lstStyle/>
+          <a:p>
+            <a:pPr algn="l">
+              <a:lnSpc>
+                <a:spcPct val="100000"/>
+              </a:lnSpc>
+              <a:spcAft>
+                <a:spcPts val="400"/>
+              </a:spcAft>
+            </a:pPr>
+            <a:r>
+              <a:rPr sz="980" b="1" i="0">
+                <a:solidFill>
+                  <a:srgbClr val="1D6FB8"/>
+                </a:solidFill>
+                <a:latin typeface="Calibri"/>
+              </a:rPr>
+              <a:t>________</a:t>
+            </a:r>
+          </a:p>
+        </p:txBody>
+      </p:sp>
+      <p:sp>
+        <p:nvSpPr>
+          <p:cNvPr id="45" name="Rectangle 44"/>
+          <p:cNvSpPr/>
+          <p:nvPr/>
+        </p:nvSpPr>
+        <p:spPr>
+          <a:xfrm>
+            <a:off x="6199632" y="3639311"/>
+            <a:ext cx="411480" cy="310896"/>
+          </a:xfrm>
+          <a:prstGeom prst="rect">
+            <a:avLst/>
+          </a:prstGeom>
+          <a:solidFill>
+            <a:srgbClr val="FFFFFF"/>
+          </a:solidFill>
+          <a:ln w="9525">
+            <a:solidFill>
+              <a:srgbClr val="DCE3EE"/>
+            </a:solidFill>
+          </a:ln>
+          <a:effectLst/>
+        </p:spPr>
+        <p:style>
+          <a:lnRef idx="1">
+            <a:schemeClr val="accent1"/>
+          </a:lnRef>
+          <a:fillRef idx="3">
+            <a:schemeClr val="accent1"/>
+          </a:fillRef>
+          <a:effectRef idx="2">
+            <a:schemeClr val="accent1"/>
+          </a:effectRef>
+          <a:fontRef idx="minor">
+            <a:schemeClr val="lt1"/>
+          </a:fontRef>
+        </p:style>
+        <p:txBody>
+          <a:bodyPr rtlCol="0" anchor="ctr"/>
+          <a:lstStyle/>
+          <a:p>
+            <a:pPr algn="ctr"/>
+          </a:p>
+        </p:txBody>
+      </p:sp>
+      <p:sp>
+        <p:nvSpPr>
+          <p:cNvPr id="46" name="TextBox 45"/>
+          <p:cNvSpPr txBox="1"/>
+          <p:nvPr/>
+        </p:nvSpPr>
+        <p:spPr>
+          <a:xfrm>
+            <a:off x="6281928" y="3703319"/>
+            <a:ext cx="265176" cy="219456"/>
+          </a:xfrm>
+          <a:prstGeom prst="rect">
+            <a:avLst/>
+          </a:prstGeom>
+          <a:noFill/>
+        </p:spPr>
+        <p:txBody>
+          <a:bodyPr wrap="square" anchor="t" lIns="0" rIns="0" tIns="0" bIns="0">
+            <a:spAutoFit/>
+          </a:bodyPr>
+          <a:lstStyle/>
+          <a:p>
+            <a:pPr algn="l">
+              <a:lnSpc>
+                <a:spcPct val="100000"/>
+              </a:lnSpc>
+              <a:spcAft>
+                <a:spcPts val="400"/>
+              </a:spcAft>
+            </a:pPr>
+            <a:r>
+              <a:rPr sz="980" b="1" i="0">
+                <a:solidFill>
+                  <a:srgbClr val="16325C"/>
+                </a:solidFill>
+                <a:latin typeface="Calibri"/>
+              </a:rPr>
+              <a:t>E</a:t>
+            </a:r>
+          </a:p>
+        </p:txBody>
+      </p:sp>
+      <p:sp>
+        <p:nvSpPr>
+          <p:cNvPr id="47" name="Rectangle 46"/>
+          <p:cNvSpPr/>
+          <p:nvPr/>
+        </p:nvSpPr>
+        <p:spPr>
+          <a:xfrm>
+            <a:off x="6611112" y="3639311"/>
+            <a:ext cx="3611880" cy="310896"/>
+          </a:xfrm>
+          <a:prstGeom prst="rect">
+            <a:avLst/>
+          </a:prstGeom>
+          <a:solidFill>
+            <a:srgbClr val="FFFFFF"/>
+          </a:solidFill>
+          <a:ln w="9525">
+            <a:solidFill>
+              <a:srgbClr val="DCE3EE"/>
+            </a:solidFill>
+          </a:ln>
+          <a:effectLst/>
+        </p:spPr>
+        <p:style>
+          <a:lnRef idx="1">
+            <a:schemeClr val="accent1"/>
+          </a:lnRef>
+          <a:fillRef idx="3">
+            <a:schemeClr val="accent1"/>
+          </a:fillRef>
+          <a:effectRef idx="2">
+            <a:schemeClr val="accent1"/>
+          </a:effectRef>
+          <a:fontRef idx="minor">
+            <a:schemeClr val="lt1"/>
+          </a:fontRef>
+        </p:style>
+        <p:txBody>
+          <a:bodyPr rtlCol="0" anchor="ctr"/>
+          <a:lstStyle/>
+          <a:p>
+            <a:pPr algn="ctr"/>
+          </a:p>
+        </p:txBody>
+      </p:sp>
+      <p:sp>
+        <p:nvSpPr>
+          <p:cNvPr id="48" name="TextBox 47"/>
+          <p:cNvSpPr txBox="1"/>
+          <p:nvPr/>
+        </p:nvSpPr>
+        <p:spPr>
+          <a:xfrm>
+            <a:off x="6693408" y="3703319"/>
+            <a:ext cx="3465576" cy="219456"/>
+          </a:xfrm>
+          <a:prstGeom prst="rect">
+            <a:avLst/>
+          </a:prstGeom>
+          <a:noFill/>
+        </p:spPr>
+        <p:txBody>
+          <a:bodyPr wrap="square" anchor="t" lIns="0" rIns="0" tIns="0" bIns="0">
+            <a:spAutoFit/>
+          </a:bodyPr>
+          <a:lstStyle/>
+          <a:p>
+            <a:pPr algn="l">
+              <a:lnSpc>
+                <a:spcPct val="100000"/>
+              </a:lnSpc>
+              <a:spcAft>
+                <a:spcPts val="400"/>
+              </a:spcAft>
+            </a:pPr>
+            <a:r>
+              <a:rPr sz="980" b="0" i="0">
+                <a:solidFill>
+                  <a:srgbClr val="3A4356"/>
+                </a:solidFill>
+                <a:latin typeface="Calibri"/>
+              </a:rPr>
+              <a:t>Share of those values the software fills itself</a:t>
+            </a:r>
+          </a:p>
+        </p:txBody>
+      </p:sp>
+      <p:sp>
+        <p:nvSpPr>
+          <p:cNvPr id="49" name="Rectangle 48"/>
+          <p:cNvSpPr/>
+          <p:nvPr/>
+        </p:nvSpPr>
+        <p:spPr>
+          <a:xfrm>
+            <a:off x="10222992" y="3639311"/>
+            <a:ext cx="1554480" cy="310896"/>
+          </a:xfrm>
+          <a:prstGeom prst="rect">
+            <a:avLst/>
+          </a:prstGeom>
+          <a:solidFill>
+            <a:srgbClr val="FFFFFF"/>
+          </a:solidFill>
+          <a:ln w="9525">
+            <a:solidFill>
+              <a:srgbClr val="DCE3EE"/>
+            </a:solidFill>
+          </a:ln>
+          <a:effectLst/>
+        </p:spPr>
+        <p:style>
+          <a:lnRef idx="1">
+            <a:schemeClr val="accent1"/>
+          </a:lnRef>
+          <a:fillRef idx="3">
+            <a:schemeClr val="accent1"/>
+          </a:fillRef>
+          <a:effectRef idx="2">
+            <a:schemeClr val="accent1"/>
+          </a:effectRef>
+          <a:fontRef idx="minor">
+            <a:schemeClr val="lt1"/>
+          </a:fontRef>
+        </p:style>
+        <p:txBody>
+          <a:bodyPr rtlCol="0" anchor="ctr"/>
+          <a:lstStyle/>
+          <a:p>
+            <a:pPr algn="ctr"/>
+          </a:p>
+        </p:txBody>
+      </p:sp>
+      <p:sp>
+        <p:nvSpPr>
+          <p:cNvPr id="50" name="TextBox 49"/>
+          <p:cNvSpPr txBox="1"/>
+          <p:nvPr/>
+        </p:nvSpPr>
+        <p:spPr>
+          <a:xfrm>
+            <a:off x="10305288" y="3703319"/>
+            <a:ext cx="1408176" cy="219456"/>
+          </a:xfrm>
+          <a:prstGeom prst="rect">
+            <a:avLst/>
+          </a:prstGeom>
+          <a:noFill/>
+        </p:spPr>
+        <p:txBody>
+          <a:bodyPr wrap="square" anchor="t" lIns="0" rIns="0" tIns="0" bIns="0">
+            <a:spAutoFit/>
+          </a:bodyPr>
+          <a:lstStyle/>
+          <a:p>
+            <a:pPr algn="l">
+              <a:lnSpc>
+                <a:spcPct val="100000"/>
+              </a:lnSpc>
+              <a:spcAft>
+                <a:spcPts val="400"/>
+              </a:spcAft>
+            </a:pPr>
+            <a:r>
+              <a:rPr sz="980" b="1" i="0">
+                <a:solidFill>
+                  <a:srgbClr val="2E8B57"/>
+                </a:solidFill>
+                <a:latin typeface="Calibri"/>
+              </a:rPr>
+              <a:t>________</a:t>
+            </a:r>
+          </a:p>
+        </p:txBody>
+      </p:sp>
+      <p:sp>
+        <p:nvSpPr>
+          <p:cNvPr id="51" name="Rounded Rectangle 50"/>
+          <p:cNvSpPr/>
+          <p:nvPr/>
+        </p:nvSpPr>
+        <p:spPr>
+          <a:xfrm>
+            <a:off x="6199632" y="4206240"/>
+            <a:ext cx="5577840" cy="530352"/>
+          </a:xfrm>
+          <a:prstGeom prst="roundRect">
+            <a:avLst>
+              <a:gd name="adj" fmla="val 12000"/>
+            </a:avLst>
+          </a:prstGeom>
+          <a:solidFill>
+            <a:srgbClr val="FFFFFF"/>
+          </a:solidFill>
+          <a:ln w="9525">
+            <a:solidFill>
+              <a:srgbClr val="DCE3EE"/>
+            </a:solidFill>
+          </a:ln>
+          <a:effectLst/>
+        </p:spPr>
+        <p:style>
+          <a:lnRef idx="1">
+            <a:schemeClr val="accent1"/>
+          </a:lnRef>
+          <a:fillRef idx="3">
+            <a:schemeClr val="accent1"/>
+          </a:fillRef>
+          <a:effectRef idx="2">
+            <a:schemeClr val="accent1"/>
+          </a:effectRef>
+          <a:fontRef idx="minor">
+            <a:schemeClr val="lt1"/>
+          </a:fontRef>
+        </p:style>
+        <p:txBody>
+          <a:bodyPr rtlCol="0" anchor="ctr"/>
+          <a:lstStyle/>
+          <a:p>
+            <a:pPr algn="ctr"/>
+          </a:p>
+        </p:txBody>
+      </p:sp>
+      <p:sp>
+        <p:nvSpPr>
+          <p:cNvPr id="52" name="Rectangle 51"/>
+          <p:cNvSpPr/>
+          <p:nvPr/>
+        </p:nvSpPr>
+        <p:spPr>
+          <a:xfrm>
+            <a:off x="6199632" y="4206240"/>
+            <a:ext cx="68580" cy="530352"/>
+          </a:xfrm>
+          <a:prstGeom prst="rect">
+            <a:avLst/>
+          </a:prstGeom>
+          <a:solidFill>
+            <a:srgbClr val="B03A2E"/>
+          </a:solidFill>
+          <a:ln>
+            <a:noFill/>
+          </a:ln>
+          <a:effectLst/>
+        </p:spPr>
+        <p:style>
+          <a:lnRef idx="1">
+            <a:schemeClr val="accent1"/>
+          </a:lnRef>
+          <a:fillRef idx="3">
+            <a:schemeClr val="accent1"/>
+          </a:fillRef>
+          <a:effectRef idx="2">
+            <a:schemeClr val="accent1"/>
+          </a:effectRef>
+          <a:fontRef idx="minor">
+            <a:schemeClr val="lt1"/>
+          </a:fontRef>
+        </p:style>
+        <p:txBody>
+          <a:bodyPr rtlCol="0" anchor="ctr"/>
+          <a:lstStyle/>
+          <a:p>
+            <a:pPr algn="ctr"/>
+          </a:p>
+        </p:txBody>
+      </p:sp>
+      <p:sp>
+        <p:nvSpPr>
+          <p:cNvPr id="53" name="TextBox 52"/>
+          <p:cNvSpPr txBox="1"/>
+          <p:nvPr/>
+        </p:nvSpPr>
+        <p:spPr>
+          <a:xfrm>
+            <a:off x="6419088" y="4343400"/>
+            <a:ext cx="3200400" cy="256032"/>
+          </a:xfrm>
+          <a:prstGeom prst="rect">
+            <a:avLst/>
+          </a:prstGeom>
+          <a:noFill/>
+        </p:spPr>
+        <p:txBody>
+          <a:bodyPr wrap="square" anchor="t" lIns="0" rIns="0" tIns="0" bIns="0">
+            <a:spAutoFit/>
+          </a:bodyPr>
+          <a:lstStyle/>
+          <a:p>
+            <a:pPr algn="l">
+              <a:lnSpc>
+                <a:spcPct val="100000"/>
+              </a:lnSpc>
+              <a:spcAft>
+                <a:spcPts val="400"/>
+              </a:spcAft>
+            </a:pPr>
+            <a:r>
+              <a:rPr sz="1050" b="1" i="0">
+                <a:solidFill>
+                  <a:srgbClr val="16325C"/>
+                </a:solidFill>
+                <a:latin typeface="Calibri"/>
+              </a:rPr>
+              <a:t>Hours spent typing today</a:t>
+            </a:r>
+          </a:p>
+        </p:txBody>
+      </p:sp>
+      <p:sp>
+        <p:nvSpPr>
+          <p:cNvPr id="54" name="TextBox 53"/>
+          <p:cNvSpPr txBox="1"/>
+          <p:nvPr/>
+        </p:nvSpPr>
+        <p:spPr>
+          <a:xfrm>
+            <a:off x="9646920" y="4325112"/>
+            <a:ext cx="2011680" cy="274320"/>
+          </a:xfrm>
+          <a:prstGeom prst="rect">
+            <a:avLst/>
+          </a:prstGeom>
+          <a:noFill/>
+        </p:spPr>
+        <p:txBody>
+          <a:bodyPr wrap="square" anchor="t" lIns="0" rIns="0" tIns="0" bIns="0">
+            <a:spAutoFit/>
+          </a:bodyPr>
+          <a:lstStyle/>
+          <a:p>
+            <a:pPr algn="r">
+              <a:lnSpc>
+                <a:spcPct val="100000"/>
+              </a:lnSpc>
+              <a:spcAft>
+                <a:spcPts val="400"/>
+              </a:spcAft>
+            </a:pPr>
+            <a:r>
+              <a:rPr sz="1250" b="1" i="0">
+                <a:solidFill>
+                  <a:srgbClr val="B03A2E"/>
+                </a:solidFill>
+                <a:latin typeface="Calibri"/>
+              </a:rPr>
+              <a:t>B × C ÷ 60</a:t>
+            </a:r>
+          </a:p>
+        </p:txBody>
+      </p:sp>
+      <p:sp>
+        <p:nvSpPr>
+          <p:cNvPr id="55" name="Rounded Rectangle 54"/>
+          <p:cNvSpPr/>
+          <p:nvPr/>
+        </p:nvSpPr>
+        <p:spPr>
+          <a:xfrm>
+            <a:off x="6199632" y="4773168"/>
+            <a:ext cx="5577840" cy="530352"/>
+          </a:xfrm>
+          <a:prstGeom prst="roundRect">
+            <a:avLst>
+              <a:gd name="adj" fmla="val 12000"/>
+            </a:avLst>
+          </a:prstGeom>
+          <a:solidFill>
+            <a:srgbClr val="FFFFFF"/>
+          </a:solidFill>
+          <a:ln w="9525">
+            <a:solidFill>
+              <a:srgbClr val="DCE3EE"/>
+            </a:solidFill>
+          </a:ln>
+          <a:effectLst/>
+        </p:spPr>
+        <p:style>
+          <a:lnRef idx="1">
+            <a:schemeClr val="accent1"/>
+          </a:lnRef>
+          <a:fillRef idx="3">
+            <a:schemeClr val="accent1"/>
+          </a:fillRef>
+          <a:effectRef idx="2">
+            <a:schemeClr val="accent1"/>
+          </a:effectRef>
+          <a:fontRef idx="minor">
+            <a:schemeClr val="lt1"/>
+          </a:fontRef>
+        </p:style>
+        <p:txBody>
+          <a:bodyPr rtlCol="0" anchor="ctr"/>
+          <a:lstStyle/>
+          <a:p>
+            <a:pPr algn="ctr"/>
+          </a:p>
+        </p:txBody>
+      </p:sp>
+      <p:sp>
+        <p:nvSpPr>
+          <p:cNvPr id="56" name="Rectangle 55"/>
+          <p:cNvSpPr/>
+          <p:nvPr/>
+        </p:nvSpPr>
+        <p:spPr>
+          <a:xfrm>
+            <a:off x="6199632" y="4773168"/>
+            <a:ext cx="68580" cy="530352"/>
+          </a:xfrm>
+          <a:prstGeom prst="rect">
+            <a:avLst/>
+          </a:prstGeom>
+          <a:solidFill>
+            <a:srgbClr val="2E8B57"/>
+          </a:solidFill>
+          <a:ln>
+            <a:noFill/>
+          </a:ln>
+          <a:effectLst/>
+        </p:spPr>
+        <p:style>
+          <a:lnRef idx="1">
+            <a:schemeClr val="accent1"/>
+          </a:lnRef>
+          <a:fillRef idx="3">
+            <a:schemeClr val="accent1"/>
+          </a:fillRef>
+          <a:effectRef idx="2">
+            <a:schemeClr val="accent1"/>
+          </a:effectRef>
+          <a:fontRef idx="minor">
+            <a:schemeClr val="lt1"/>
+          </a:fontRef>
+        </p:style>
+        <p:txBody>
+          <a:bodyPr rtlCol="0" anchor="ctr"/>
+          <a:lstStyle/>
+          <a:p>
+            <a:pPr algn="ctr"/>
+          </a:p>
+        </p:txBody>
+      </p:sp>
+      <p:sp>
+        <p:nvSpPr>
+          <p:cNvPr id="57" name="TextBox 56"/>
+          <p:cNvSpPr txBox="1"/>
+          <p:nvPr/>
+        </p:nvSpPr>
+        <p:spPr>
+          <a:xfrm>
+            <a:off x="6419088" y="4910328"/>
+            <a:ext cx="3200400" cy="256032"/>
+          </a:xfrm>
+          <a:prstGeom prst="rect">
+            <a:avLst/>
+          </a:prstGeom>
+          <a:noFill/>
+        </p:spPr>
+        <p:txBody>
+          <a:bodyPr wrap="square" anchor="t" lIns="0" rIns="0" tIns="0" bIns="0">
+            <a:spAutoFit/>
+          </a:bodyPr>
+          <a:lstStyle/>
+          <a:p>
+            <a:pPr algn="l">
+              <a:lnSpc>
+                <a:spcPct val="100000"/>
+              </a:lnSpc>
+              <a:spcAft>
+                <a:spcPts val="400"/>
+              </a:spcAft>
+            </a:pPr>
+            <a:r>
+              <a:rPr sz="1050" b="1" i="0">
+                <a:solidFill>
+                  <a:srgbClr val="16325C"/>
+                </a:solidFill>
+                <a:latin typeface="Calibri"/>
+              </a:rPr>
+              <a:t>Hours freed a year</a:t>
+            </a:r>
+          </a:p>
+        </p:txBody>
+      </p:sp>
+      <p:sp>
+        <p:nvSpPr>
+          <p:cNvPr id="58" name="TextBox 57"/>
+          <p:cNvSpPr txBox="1"/>
+          <p:nvPr/>
+        </p:nvSpPr>
+        <p:spPr>
+          <a:xfrm>
+            <a:off x="9646920" y="4892040"/>
+            <a:ext cx="2011680" cy="274320"/>
+          </a:xfrm>
+          <a:prstGeom prst="rect">
+            <a:avLst/>
+          </a:prstGeom>
+          <a:noFill/>
+        </p:spPr>
+        <p:txBody>
+          <a:bodyPr wrap="square" anchor="t" lIns="0" rIns="0" tIns="0" bIns="0">
+            <a:spAutoFit/>
+          </a:bodyPr>
+          <a:lstStyle/>
+          <a:p>
+            <a:pPr algn="r">
+              <a:lnSpc>
+                <a:spcPct val="100000"/>
+              </a:lnSpc>
+              <a:spcAft>
+                <a:spcPts val="400"/>
+              </a:spcAft>
+            </a:pPr>
+            <a:r>
+              <a:rPr sz="1250" b="1" i="0">
+                <a:solidFill>
+                  <a:srgbClr val="2E8B57"/>
+                </a:solidFill>
+                <a:latin typeface="Calibri"/>
+              </a:rPr>
+              <a:t>B × E × C ÷ 60</a:t>
+            </a:r>
+          </a:p>
+        </p:txBody>
+      </p:sp>
+      <p:sp>
+        <p:nvSpPr>
+          <p:cNvPr id="59" name="Rounded Rectangle 58"/>
+          <p:cNvSpPr/>
+          <p:nvPr/>
+        </p:nvSpPr>
+        <p:spPr>
+          <a:xfrm>
+            <a:off x="6199632" y="5340096"/>
+            <a:ext cx="5577840" cy="530352"/>
+          </a:xfrm>
+          <a:prstGeom prst="roundRect">
+            <a:avLst>
+              <a:gd name="adj" fmla="val 12000"/>
+            </a:avLst>
+          </a:prstGeom>
+          <a:solidFill>
+            <a:srgbClr val="FFFFFF"/>
+          </a:solidFill>
+          <a:ln w="9525">
+            <a:solidFill>
+              <a:srgbClr val="DCE3EE"/>
+            </a:solidFill>
+          </a:ln>
+          <a:effectLst/>
+        </p:spPr>
+        <p:style>
+          <a:lnRef idx="1">
+            <a:schemeClr val="accent1"/>
+          </a:lnRef>
+          <a:fillRef idx="3">
+            <a:schemeClr val="accent1"/>
+          </a:fillRef>
+          <a:effectRef idx="2">
+            <a:schemeClr val="accent1"/>
+          </a:effectRef>
+          <a:fontRef idx="minor">
+            <a:schemeClr val="lt1"/>
+          </a:fontRef>
+        </p:style>
+        <p:txBody>
+          <a:bodyPr rtlCol="0" anchor="ctr"/>
+          <a:lstStyle/>
+          <a:p>
+            <a:pPr algn="ctr"/>
+          </a:p>
+        </p:txBody>
+      </p:sp>
+      <p:sp>
+        <p:nvSpPr>
+          <p:cNvPr id="60" name="Rectangle 59"/>
+          <p:cNvSpPr/>
+          <p:nvPr/>
+        </p:nvSpPr>
+        <p:spPr>
+          <a:xfrm>
+            <a:off x="6199632" y="5340096"/>
+            <a:ext cx="68580" cy="530352"/>
+          </a:xfrm>
+          <a:prstGeom prst="rect">
+            <a:avLst/>
+          </a:prstGeom>
+          <a:solidFill>
+            <a:srgbClr val="1D6FB8"/>
+          </a:solidFill>
+          <a:ln>
+            <a:noFill/>
+          </a:ln>
+          <a:effectLst/>
+        </p:spPr>
+        <p:style>
+          <a:lnRef idx="1">
+            <a:schemeClr val="accent1"/>
+          </a:lnRef>
+          <a:fillRef idx="3">
+            <a:schemeClr val="accent1"/>
+          </a:fillRef>
+          <a:effectRef idx="2">
+            <a:schemeClr val="accent1"/>
+          </a:effectRef>
+          <a:fontRef idx="minor">
+            <a:schemeClr val="lt1"/>
+          </a:fontRef>
+        </p:style>
+        <p:txBody>
+          <a:bodyPr rtlCol="0" anchor="ctr"/>
+          <a:lstStyle/>
+          <a:p>
+            <a:pPr algn="ctr"/>
+          </a:p>
+        </p:txBody>
+      </p:sp>
+      <p:sp>
+        <p:nvSpPr>
+          <p:cNvPr id="61" name="TextBox 60"/>
+          <p:cNvSpPr txBox="1"/>
+          <p:nvPr/>
+        </p:nvSpPr>
+        <p:spPr>
+          <a:xfrm>
+            <a:off x="6419088" y="5477256"/>
+            <a:ext cx="3200400" cy="256032"/>
+          </a:xfrm>
+          <a:prstGeom prst="rect">
+            <a:avLst/>
+          </a:prstGeom>
+          <a:noFill/>
+        </p:spPr>
+        <p:txBody>
+          <a:bodyPr wrap="square" anchor="t" lIns="0" rIns="0" tIns="0" bIns="0">
+            <a:spAutoFit/>
+          </a:bodyPr>
+          <a:lstStyle/>
+          <a:p>
+            <a:pPr algn="l">
+              <a:lnSpc>
+                <a:spcPct val="100000"/>
+              </a:lnSpc>
+              <a:spcAft>
+                <a:spcPts val="400"/>
+              </a:spcAft>
+            </a:pPr>
+            <a:r>
+              <a:rPr sz="1050" b="1" i="0">
+                <a:solidFill>
+                  <a:srgbClr val="16325C"/>
+                </a:solidFill>
+                <a:latin typeface="Calibri"/>
+              </a:rPr>
+              <a:t>Extra parts that time would cost</a:t>
+            </a:r>
+          </a:p>
+        </p:txBody>
+      </p:sp>
+      <p:sp>
+        <p:nvSpPr>
+          <p:cNvPr id="62" name="TextBox 61"/>
+          <p:cNvSpPr txBox="1"/>
+          <p:nvPr/>
+        </p:nvSpPr>
+        <p:spPr>
+          <a:xfrm>
+            <a:off x="9646920" y="5458968"/>
+            <a:ext cx="2011680" cy="274320"/>
+          </a:xfrm>
+          <a:prstGeom prst="rect">
+            <a:avLst/>
+          </a:prstGeom>
+          <a:noFill/>
+        </p:spPr>
+        <p:txBody>
+          <a:bodyPr wrap="square" anchor="t" lIns="0" rIns="0" tIns="0" bIns="0">
+            <a:spAutoFit/>
+          </a:bodyPr>
+          <a:lstStyle/>
+          <a:p>
+            <a:pPr algn="r">
+              <a:lnSpc>
+                <a:spcPct val="100000"/>
+              </a:lnSpc>
+              <a:spcAft>
+                <a:spcPts val="400"/>
+              </a:spcAft>
+            </a:pPr>
+            <a:r>
+              <a:rPr sz="1250" b="1" i="0">
+                <a:solidFill>
+                  <a:srgbClr val="1D6FB8"/>
+                </a:solidFill>
+                <a:latin typeface="Calibri"/>
+              </a:rPr>
+              <a:t>B × E × C ÷ A</a:t>
+            </a:r>
+          </a:p>
+        </p:txBody>
+      </p:sp>
+      <p:sp>
+        <p:nvSpPr>
+          <p:cNvPr id="63" name="Rounded Rectangle 62"/>
+          <p:cNvSpPr/>
+          <p:nvPr/>
+        </p:nvSpPr>
+        <p:spPr>
+          <a:xfrm>
+            <a:off x="411480" y="5998464"/>
+            <a:ext cx="11365992" cy="749808"/>
+          </a:xfrm>
+          <a:prstGeom prst="roundRect">
+            <a:avLst>
+              <a:gd name="adj" fmla="val 12000"/>
+            </a:avLst>
+          </a:prstGeom>
+          <a:solidFill>
+            <a:srgbClr val="EAF6EF"/>
+          </a:solidFill>
+          <a:ln>
+            <a:noFill/>
+          </a:ln>
+          <a:effectLst/>
+        </p:spPr>
+        <p:style>
+          <a:lnRef idx="1">
+            <a:schemeClr val="accent1"/>
+          </a:lnRef>
+          <a:fillRef idx="3">
+            <a:schemeClr val="accent1"/>
+          </a:fillRef>
+          <a:effectRef idx="2">
+            <a:schemeClr val="accent1"/>
+          </a:effectRef>
+          <a:fontRef idx="minor">
+            <a:schemeClr val="lt1"/>
+          </a:fontRef>
+        </p:style>
+        <p:txBody>
+          <a:bodyPr rtlCol="0" anchor="ctr"/>
+          <a:lstStyle/>
+          <a:p>
+            <a:pPr algn="ctr"/>
+          </a:p>
+        </p:txBody>
+      </p:sp>
+      <p:sp>
+        <p:nvSpPr>
+          <p:cNvPr id="64" name="Rectangle 63"/>
+          <p:cNvSpPr/>
+          <p:nvPr/>
+        </p:nvSpPr>
+        <p:spPr>
+          <a:xfrm>
+            <a:off x="411480" y="5998464"/>
+            <a:ext cx="68580" cy="749808"/>
+          </a:xfrm>
+          <a:prstGeom prst="rect">
+            <a:avLst/>
+          </a:prstGeom>
+          <a:solidFill>
+            <a:srgbClr val="2E8B57"/>
+          </a:solidFill>
+          <a:ln>
+            <a:noFill/>
+          </a:ln>
+          <a:effectLst/>
+        </p:spPr>
+        <p:style>
+          <a:lnRef idx="1">
+            <a:schemeClr val="accent1"/>
+          </a:lnRef>
+          <a:fillRef idx="3">
+            <a:schemeClr val="accent1"/>
+          </a:fillRef>
+          <a:effectRef idx="2">
+            <a:schemeClr val="accent1"/>
+          </a:effectRef>
+          <a:fontRef idx="minor">
+            <a:schemeClr val="lt1"/>
+          </a:fontRef>
+        </p:style>
+        <p:txBody>
+          <a:bodyPr rtlCol="0" anchor="ctr"/>
+          <a:lstStyle/>
+          <a:p>
+            <a:pPr algn="ctr"/>
+          </a:p>
+        </p:txBody>
+      </p:sp>
+      <p:sp>
+        <p:nvSpPr>
+          <p:cNvPr id="65" name="TextBox 64"/>
+          <p:cNvSpPr txBox="1"/>
+          <p:nvPr/>
+        </p:nvSpPr>
+        <p:spPr>
+          <a:xfrm>
+            <a:off x="630936" y="6117336"/>
+            <a:ext cx="10954512" cy="256032"/>
+          </a:xfrm>
+          <a:prstGeom prst="rect">
+            <a:avLst/>
+          </a:prstGeom>
+          <a:noFill/>
+        </p:spPr>
+        <p:txBody>
+          <a:bodyPr wrap="square" anchor="t" lIns="0" rIns="0" tIns="0" bIns="0">
+            <a:spAutoFit/>
+          </a:bodyPr>
+          <a:lstStyle/>
+          <a:p>
+            <a:pPr algn="l">
+              <a:lnSpc>
+                <a:spcPct val="100000"/>
+              </a:lnSpc>
+              <a:spcAft>
+                <a:spcPts val="400"/>
+              </a:spcAft>
+            </a:pPr>
+            <a:r>
               <a:rPr sz="1200" b="1" i="0">
                 <a:solidFill>
                   <a:srgbClr val="2E8B57"/>
@@ -5143,14 +6727,14 @@
       </p:sp>
       <p:sp>
         <p:nvSpPr>
-          <p:cNvPr id="36" name="TextBox 35"/>
+          <p:cNvPr id="66" name="TextBox 65"/>
           <p:cNvSpPr txBox="1"/>
           <p:nvPr/>
         </p:nvSpPr>
         <p:spPr>
           <a:xfrm>
-            <a:off x="630936" y="6071616"/>
-            <a:ext cx="10954512" cy="411480"/>
+            <a:off x="630936" y="6400800"/>
+            <a:ext cx="10954512" cy="246888"/>
           </a:xfrm>
           <a:prstGeom prst="rect">
             <a:avLst/>

</xml_diff>

<commit_message>
Slide 4: Option 1's column rebuilt around the data-entry time
Five loose benefits become seven, all pointed at the same thing — the
time spent putting numbers into CAPEE by hand.

The typing goes (12 to 69 values a part); with nothing typed there is
nothing to mistype and nothing to re-check; the same answer every time;
a re-cost is nearly free because a new volume or new rates does not mean
reading the model again; the saving repeats on every part rather than
being a one-off; what is left is the judgement, named concretely as
material, tolerance, finish and heat treatment; and it can start now.
A closing line points back at slide 1, where those become hours.

Still no time figure claimed. We have never timed the job, and the
empty-box model on slide 1 remains the only place a number appears.

Speaker notes for the slide rewritten to walk the new column.

Co-Authored-By: Claude Opus 5 <noreply@anthropic.com>
Claude-Session: https://claude.ai/code/session_0142L4rKS2AV8rxQTDWMs7dy
</commit_message>
<xml_diff>
--- a/CostVision-CAPEE-Business-Case.pptx
+++ b/CostVision-CAPEE-Business-Case.pptx
@@ -719,7 +719,7 @@
           <a:lstStyle/>
           <a:p>
             <a:r>
-              <a:t>This is what we get for it, written in kind rather than in pounds, for the reason I gave on the first slide: we have never timed this job and never checked the tool against a price we paid, so a pound figure from me would be a guess. The left column is Option one, and it is short on purpose. The job turns from typing into checking, because the values come off the model. It gives the same answer every time, so parts costed by different engineers are comparable. The time freed goes back into costing more parts with the team we already have. Nobody learns a new tool. And it can start now, because there is no AI in it to approve. The right column is wider because Option two genuinely has more in it. It runs on its own — parts go in and costed reports come out, and a person answers only what the model cannot show. It uses the same method for everything we make, so a plastic clip and a machined bracket are built up the same way and can sit in the same report. It costs electronics from a photograph of the board, which is work we largely cannot do today. It costs software as well: forty-three modules, from powertrain and driver assistance through to the cloud back end, which matters more every programme. Then the second half of that column is the part I would put to purchasing. It shows where a supplier's price differs from our own build-up and which part of the cost the gap sits in. Then it tells us what to do about it: what to go after, what to ask them, and what it is worth over a year. A whole RFQ pack can go in and come back priced and put in order of money. And design changes come back with a price on them rather than as a list of suggestions. The green strip is the sequencing point. Option one's benefits arrive first and we keep them. Option two's depend on the accuracy figure Option one produces, which is why these are an order rather than a choice.</a:t>
+              <a:t>This is what we get for it, written in kind rather than in pounds, for the reason I gave on the first slide: we have never timed this job and never checked the tool against a price we paid, so a pound figure from me would be a guess. The left column is Option one, and it is all about the same thing: the time we spend putting numbers into CAPEE by hand. The typing goes — between twelve and sixty-nine values a part, depending on the commodity, now filled from the model. With nothing typed there is nothing to mistype, so the checking of our own transcription goes with it. It gives the same answer every time, so parts costed by different engineers are comparable. Re-costing becomes nearly free: a new volume or a new set of rates does not mean reading the model again. And the saving is not a one-off — it repeats on every part, so it grows with how many we cost. What is left is the judgement: material, tolerance class, finish and heat treatment, the calls only we can make. That column can start now, because there is no AI in it to approve. And the last line points back at slide one: put our four numbers in and all of that becomes hours. The right column is wider because Option two genuinely has more in it. It runs on its own — parts go in and costed reports come out, and a person answers only what the model cannot show. It uses the same method for everything we make, so a plastic clip and a machined bracket are built up the same way and can sit in the same report. It costs electronics from a photograph of the board, which is work we largely cannot do today. It costs software as well: forty-three modules, from powertrain and driver assistance through to the cloud back end, which matters more every programme. Then the second half of that column is the part I would put to purchasing. It shows where a supplier's price differs from our own build-up and which part of the cost the gap sits in. Then it tells us what to do about it: what to go after, what to ask them, and what it is worth over a year. A whole RFQ pack can go in and come back priced and put in order of money. And design changes come back with a price on them rather than as a list of suggestions. The green strip is the sequencing point. Option one's benefits arrive first and we keep them. Option two's depend on the accuracy figure Option one produces, which is why these are an order rather than a choice.</a:t>
             </a:r>
           </a:p>
         </p:txBody>
@@ -11566,7 +11566,7 @@
         <p:spPr>
           <a:xfrm>
             <a:off x="411480" y="1810512"/>
-            <a:ext cx="3611880" cy="4206240"/>
+            <a:ext cx="3611880" cy="4297680"/>
           </a:xfrm>
           <a:prstGeom prst="roundRect">
             <a:avLst>
@@ -11614,7 +11614,7 @@
         <p:spPr>
           <a:xfrm>
             <a:off x="411480" y="1810512"/>
-            <a:ext cx="68580" cy="4206240"/>
+            <a:ext cx="68580" cy="4297680"/>
           </a:xfrm>
           <a:prstGeom prst="rect">
             <a:avLst/>
@@ -11700,7 +11700,7 @@
         <p:spPr>
           <a:xfrm>
             <a:off x="612648" y="2249424"/>
-            <a:ext cx="3246120" cy="3657600"/>
+            <a:ext cx="3246120" cy="3749040"/>
           </a:xfrm>
           <a:prstGeom prst="rect">
             <a:avLst/>
@@ -11728,7 +11728,7 @@
                 </a:solidFill>
                 <a:latin typeface="Calibri"/>
               </a:rPr>
-              <a:t>Checking instead of typing</a:t>
+              <a:t>The typing goes</a:t>
             </a:r>
           </a:p>
           <a:p>
@@ -11747,7 +11747,7 @@
                 </a:solidFill>
                 <a:latin typeface="Calibri"/>
               </a:rPr>
-              <a:t>The values come off the 3D model.</a:t>
+              <a:t>Between 12 and 69 values per part.</a:t>
             </a:r>
           </a:p>
           <a:p>
@@ -11759,6 +11759,15 @@
                 <a:spcPts val="300"/>
               </a:spcAft>
             </a:pPr>
+            <a:r>
+              <a:rPr sz="1050" b="1" i="0">
+                <a:solidFill>
+                  <a:srgbClr val="1D6FB8"/>
+                </a:solidFill>
+                <a:latin typeface="Calibri"/>
+              </a:rPr>
+              <a:t>Nothing to mistype</a:t>
+            </a:r>
           </a:p>
           <a:p>
             <a:pPr algn="l">
@@ -11770,6 +11779,25 @@
               </a:spcAft>
             </a:pPr>
             <a:r>
+              <a:rPr sz="1050" b="0" i="0">
+                <a:solidFill>
+                  <a:srgbClr val="3A4356"/>
+                </a:solidFill>
+                <a:latin typeface="Calibri"/>
+              </a:rPr>
+              <a:t>And nothing to re-check afterwards.</a:t>
+            </a:r>
+          </a:p>
+          <a:p>
+            <a:pPr algn="l">
+              <a:lnSpc>
+                <a:spcPct val="112000"/>
+              </a:lnSpc>
+              <a:spcAft>
+                <a:spcPts val="300"/>
+              </a:spcAft>
+            </a:pPr>
+            <a:r>
               <a:rPr sz="1050" b="1" i="0">
                 <a:solidFill>
                   <a:srgbClr val="1D6FB8"/>
@@ -11807,6 +11835,15 @@
                 <a:spcPts val="300"/>
               </a:spcAft>
             </a:pPr>
+            <a:r>
+              <a:rPr sz="1050" b="1" i="0">
+                <a:solidFill>
+                  <a:srgbClr val="1D6FB8"/>
+                </a:solidFill>
+                <a:latin typeface="Calibri"/>
+              </a:rPr>
+              <a:t>A re-cost is nearly free</a:t>
+            </a:r>
           </a:p>
           <a:p>
             <a:pPr algn="l">
@@ -11818,13 +11855,32 @@
               </a:spcAft>
             </a:pPr>
             <a:r>
+              <a:rPr sz="1050" b="0" i="0">
+                <a:solidFill>
+                  <a:srgbClr val="3A4356"/>
+                </a:solidFill>
+                <a:latin typeface="Calibri"/>
+              </a:rPr>
+              <a:t>New volume or rates, no re-reading.</a:t>
+            </a:r>
+          </a:p>
+          <a:p>
+            <a:pPr algn="l">
+              <a:lnSpc>
+                <a:spcPct val="112000"/>
+              </a:lnSpc>
+              <a:spcAft>
+                <a:spcPts val="300"/>
+              </a:spcAft>
+            </a:pPr>
+            <a:r>
               <a:rPr sz="1050" b="1" i="0">
                 <a:solidFill>
                   <a:srgbClr val="1D6FB8"/>
                 </a:solidFill>
                 <a:latin typeface="Calibri"/>
               </a:rPr>
-              <a:t>More parts for the same team</a:t>
+              <a:t>The saving repeats on every part</a:t>
             </a:r>
           </a:p>
           <a:p>
@@ -11843,7 +11899,7 @@
                 </a:solidFill>
                 <a:latin typeface="Calibri"/>
               </a:rPr>
-              <a:t>The time saved goes back into costing.</a:t>
+              <a:t>It grows with how many we cost.</a:t>
             </a:r>
           </a:p>
           <a:p>
@@ -11855,6 +11911,15 @@
                 <a:spcPts val="300"/>
               </a:spcAft>
             </a:pPr>
+            <a:r>
+              <a:rPr sz="1050" b="1" i="0">
+                <a:solidFill>
+                  <a:srgbClr val="1D6FB8"/>
+                </a:solidFill>
+                <a:latin typeface="Calibri"/>
+              </a:rPr>
+              <a:t>What is left is the judgement</a:t>
+            </a:r>
           </a:p>
           <a:p>
             <a:pPr algn="l">
@@ -11866,13 +11931,51 @@
               </a:spcAft>
             </a:pPr>
             <a:r>
+              <a:rPr sz="1050" b="0" i="0">
+                <a:solidFill>
+                  <a:srgbClr val="3A4356"/>
+                </a:solidFill>
+                <a:latin typeface="Calibri"/>
+              </a:rPr>
+              <a:t>Material, tolerance, finish, heat</a:t>
+            </a:r>
+          </a:p>
+          <a:p>
+            <a:pPr algn="l">
+              <a:lnSpc>
+                <a:spcPct val="112000"/>
+              </a:lnSpc>
+              <a:spcAft>
+                <a:spcPts val="300"/>
+              </a:spcAft>
+            </a:pPr>
+            <a:r>
+              <a:rPr sz="1050" b="0" i="0">
+                <a:solidFill>
+                  <a:srgbClr val="3A4356"/>
+                </a:solidFill>
+                <a:latin typeface="Calibri"/>
+              </a:rPr>
+              <a:t>treatment — the calls only we can make.</a:t>
+            </a:r>
+          </a:p>
+          <a:p>
+            <a:pPr algn="l">
+              <a:lnSpc>
+                <a:spcPct val="112000"/>
+              </a:lnSpc>
+              <a:spcAft>
+                <a:spcPts val="300"/>
+              </a:spcAft>
+            </a:pPr>
+            <a:r>
               <a:rPr sz="1050" b="1" i="0">
                 <a:solidFill>
                   <a:srgbClr val="1D6FB8"/>
                 </a:solidFill>
                 <a:latin typeface="Calibri"/>
               </a:rPr>
-              <a:t>Nothing new to learn</a:t>
+              <a:t>It can start now</a:t>
             </a:r>
           </a:p>
           <a:p>
@@ -11891,7 +11994,7 @@
                 </a:solidFill>
                 <a:latin typeface="Calibri"/>
               </a:rPr>
-              <a:t>CAPEE does not change.</a:t>
+              <a:t>No AI, so no approval to wait for.</a:t>
             </a:r>
           </a:p>
           <a:p>
@@ -11920,26 +12023,7 @@
                 </a:solidFill>
                 <a:latin typeface="Calibri"/>
               </a:rPr>
-              <a:t>It can start now</a:t>
-            </a:r>
-          </a:p>
-          <a:p>
-            <a:pPr algn="l">
-              <a:lnSpc>
-                <a:spcPct val="112000"/>
-              </a:lnSpc>
-              <a:spcAft>
-                <a:spcPts val="300"/>
-              </a:spcAft>
-            </a:pPr>
-            <a:r>
-              <a:rPr sz="1050" b="0" i="0">
-                <a:solidFill>
-                  <a:srgbClr val="3A4356"/>
-                </a:solidFill>
-                <a:latin typeface="Calibri"/>
-              </a:rPr>
-              <a:t>No AI, so no approval to wait for.</a:t>
+              <a:t>Slide 1 turns this into hours.</a:t>
             </a:r>
           </a:p>
         </p:txBody>
@@ -11953,7 +12037,7 @@
         <p:spPr>
           <a:xfrm>
             <a:off x="4233672" y="1810512"/>
-            <a:ext cx="7543800" cy="4206240"/>
+            <a:ext cx="7543800" cy="4297680"/>
           </a:xfrm>
           <a:prstGeom prst="roundRect">
             <a:avLst>
@@ -12001,7 +12085,7 @@
         <p:spPr>
           <a:xfrm>
             <a:off x="4233672" y="1810512"/>
-            <a:ext cx="68580" cy="4206240"/>
+            <a:ext cx="68580" cy="4297680"/>
           </a:xfrm>
           <a:prstGeom prst="rect">
             <a:avLst/>
@@ -12087,7 +12171,7 @@
         <p:spPr>
           <a:xfrm>
             <a:off x="4434840" y="2267712"/>
-            <a:ext cx="3488436" cy="3657600"/>
+            <a:ext cx="3488436" cy="3749040"/>
           </a:xfrm>
           <a:prstGeom prst="rect">
             <a:avLst/>
@@ -12368,7 +12452,7 @@
         <p:spPr>
           <a:xfrm>
             <a:off x="8087868" y="2267712"/>
-            <a:ext cx="3488436" cy="3657600"/>
+            <a:ext cx="3488436" cy="3749040"/>
           </a:xfrm>
           <a:prstGeom prst="rect">
             <a:avLst/>
@@ -12648,8 +12732,8 @@
         </p:nvSpPr>
         <p:spPr>
           <a:xfrm>
-            <a:off x="411480" y="6053328"/>
-            <a:ext cx="11365992" cy="758952"/>
+            <a:off x="411480" y="6163056"/>
+            <a:ext cx="11365992" cy="603504"/>
           </a:xfrm>
           <a:prstGeom prst="roundRect">
             <a:avLst>
@@ -12694,8 +12778,8 @@
         </p:nvSpPr>
         <p:spPr>
           <a:xfrm>
-            <a:off x="411480" y="6053328"/>
-            <a:ext cx="68580" cy="758952"/>
+            <a:off x="411480" y="6163056"/>
+            <a:ext cx="68580" cy="603504"/>
           </a:xfrm>
           <a:prstGeom prst="rect">
             <a:avLst/>
@@ -12738,7 +12822,7 @@
         </p:nvSpPr>
         <p:spPr>
           <a:xfrm>
-            <a:off x="630936" y="6172200"/>
+            <a:off x="630936" y="6281928"/>
             <a:ext cx="10954512" cy="256032"/>
           </a:xfrm>
           <a:prstGeom prst="rect">
@@ -12780,8 +12864,8 @@
         </p:nvSpPr>
         <p:spPr>
           <a:xfrm>
-            <a:off x="630936" y="6455664"/>
-            <a:ext cx="10954512" cy="256032"/>
+            <a:off x="630936" y="6565392"/>
+            <a:ext cx="10954512" cy="109728"/>
           </a:xfrm>
           <a:prstGeom prst="rect">
             <a:avLst/>
@@ -12809,7 +12893,7 @@
                 </a:solidFill>
                 <a:latin typeface="Calibri"/>
               </a:rPr>
-              <a:t>Option 1's benefits arrive first and are kept when Option 2 lands. Option 2's rest on the accuracy figure that Option 1 produces, which is why these are an order and not a choice.</a:t>
+              <a:t>Option 1's benefits arrive first and are kept when Option 2 lands; Option 2's rest on the accuracy figure Option 1 produces.</a:t>
             </a:r>
           </a:p>
         </p:txBody>

</xml_diff>